<commit_message>
Submission check: refresh numbers (248 tests), deck slide 10, TODO and docs for 19 Oct
- 239 -> 248 tests in README, SUBMISSION, TECHNICAL, SECURITY, PROJECT_SUMMARY, landing page, deck (PPTX + PDF re-exported) and slide notes
- TECHNICAL and SECURITY bumped to v0.5 (19 Oct); ten verified rules
- README tour covers the paste box, printable receipt, compliance checks and attack-lab traces
- TODO.md rewritten: registration confirmed, what is done, what is left before 20 Oct
- Evidence rerun: 27/27 scenarios, demo audit chain 153 entries verifies

Co-Authored-By: Claude Opus 5.5 <noreply@anthropic.com>
</commit_message>
<xml_diff>
--- a/docs/presentation/TuitionPilot_deck.pptx
+++ b/docs/presentation/TuitionPilot_deck.pptx
@@ -889,7 +889,7 @@
           <a:p>
             <a:r>
               <a:rPr lang="en-US"/>
-              <a:t>About 45 seconds. Everything here can be rerun with one command each. 239 tests pass. All 27 scenarios pass: ten task-completion, six safe-execution, nine attacks including a forged approval and a revoked university key, and two privacy scenarios. The attack lab stops all 16 attacks. The scripted sandbox run writes a ledger, the log of what the AI saw, and an audit log whose hash chain verifies. A finance audit of 400 random cases matched an independent formula.</a:t>
+              <a:t>About 45 seconds. Everything here can be rerun with one command each. 248 tests pass. All 27 scenarios pass: ten task-completion, six safe-execution, nine attacks including a forged approval and a revoked university key, and two privacy scenarios. The attack lab stops all 16 attacks. The scripted sandbox run writes a ledger, the log of what the AI saw, and an audit log whose hash chain verifies. A finance audit of 400 random cases matched an independent formula.</a:t>
             </a:r>
             <a:endParaRPr lang="en-US" dirty="0"/>
           </a:p>
@@ -1878,7 +1878,7 @@
           </a:prstGeom>
           <a:extLst>
             <a:ext uri="{C572A759-6A51-4108-AA02-DFA0A04FC94B}">
-              <ma14:wrappingTextBoxFlag xmlns="" xmlns:ma14="http://schemas.microsoft.com/office/mac/drawingml/2011/main" val="0"/>
+              <ma14:wrappingTextBoxFlag xmlns:ma14="http://schemas.microsoft.com/office/mac/drawingml/2011/main" xmlns="" val="0"/>
             </a:ext>
           </a:extLst>
         </p:spPr>
@@ -1989,7 +1989,7 @@
           </a:prstGeom>
           <a:extLst>
             <a:ext uri="{C572A759-6A51-4108-AA02-DFA0A04FC94B}">
-              <ma14:wrappingTextBoxFlag xmlns="" xmlns:ma14="http://schemas.microsoft.com/office/mac/drawingml/2011/main" val="0"/>
+              <ma14:wrappingTextBoxFlag xmlns:ma14="http://schemas.microsoft.com/office/mac/drawingml/2011/main" xmlns="" val="0"/>
             </a:ext>
           </a:extLst>
         </p:spPr>
@@ -2897,6 +2897,13 @@
           </a:solidFill>
           <a:ln/>
         </p:spPr>
+        <p:txBody>
+          <a:bodyPr/>
+          <a:lstStyle/>
+          <a:p>
+            <a:endParaRPr lang="en-IN"/>
+          </a:p>
+        </p:txBody>
       </p:sp>
       <p:sp>
         <p:nvSpPr>
@@ -2931,7 +2938,7 @@
                 <a:ea typeface="Cambria" pitchFamily="34" charset="-122"/>
                 <a:cs typeface="Cambria" pitchFamily="34" charset="-120"/>
               </a:rPr>
-              <a:t>239</a:t>
+              <a:t>248</a:t>
             </a:r>
             <a:endParaRPr lang="en-US" sz="4400" dirty="0"/>
           </a:p>
@@ -2997,6 +3004,13 @@
           </a:solidFill>
           <a:ln/>
         </p:spPr>
+        <p:txBody>
+          <a:bodyPr/>
+          <a:lstStyle/>
+          <a:p>
+            <a:endParaRPr lang="en-IN"/>
+          </a:p>
+        </p:txBody>
       </p:sp>
       <p:sp>
         <p:nvSpPr>
@@ -3097,6 +3111,13 @@
           </a:solidFill>
           <a:ln/>
         </p:spPr>
+        <p:txBody>
+          <a:bodyPr/>
+          <a:lstStyle/>
+          <a:p>
+            <a:endParaRPr lang="en-IN"/>
+          </a:p>
+        </p:txBody>
       </p:sp>
       <p:sp>
         <p:nvSpPr>
@@ -3197,6 +3218,13 @@
           </a:solidFill>
           <a:ln/>
         </p:spPr>
+        <p:txBody>
+          <a:bodyPr/>
+          <a:lstStyle/>
+          <a:p>
+            <a:endParaRPr lang="en-IN"/>
+          </a:p>
+        </p:txBody>
       </p:sp>
       <p:sp>
         <p:nvSpPr>
@@ -3415,6 +3443,13 @@
             <a:prstDash val="solid"/>
           </a:ln>
         </p:spPr>
+        <p:txBody>
+          <a:bodyPr/>
+          <a:lstStyle/>
+          <a:p>
+            <a:endParaRPr lang="en-IN"/>
+          </a:p>
+        </p:txBody>
       </p:sp>
       <p:sp>
         <p:nvSpPr>
@@ -3516,6 +3551,13 @@
             <a:prstDash val="solid"/>
           </a:ln>
         </p:spPr>
+        <p:txBody>
+          <a:bodyPr/>
+          <a:lstStyle/>
+          <a:p>
+            <a:endParaRPr lang="en-IN"/>
+          </a:p>
+        </p:txBody>
       </p:sp>
       <p:sp>
         <p:nvSpPr>
@@ -3617,6 +3659,13 @@
             <a:prstDash val="solid"/>
           </a:ln>
         </p:spPr>
+        <p:txBody>
+          <a:bodyPr/>
+          <a:lstStyle/>
+          <a:p>
+            <a:endParaRPr lang="en-IN"/>
+          </a:p>
+        </p:txBody>
       </p:sp>
       <p:sp>
         <p:nvSpPr>
@@ -3718,6 +3767,13 @@
             <a:prstDash val="solid"/>
           </a:ln>
         </p:spPr>
+        <p:txBody>
+          <a:bodyPr/>
+          <a:lstStyle/>
+          <a:p>
+            <a:endParaRPr lang="en-IN"/>
+          </a:p>
+        </p:txBody>
       </p:sp>
       <p:sp>
         <p:nvSpPr>
@@ -3740,6 +3796,13 @@
           </a:solidFill>
           <a:ln/>
         </p:spPr>
+        <p:txBody>
+          <a:bodyPr/>
+          <a:lstStyle/>
+          <a:p>
+            <a:endParaRPr lang="en-IN"/>
+          </a:p>
+        </p:txBody>
       </p:sp>
       <p:sp>
         <p:nvSpPr>
@@ -4589,7 +4652,7 @@
           </a:prstGeom>
           <a:extLst>
             <a:ext uri="{C572A759-6A51-4108-AA02-DFA0A04FC94B}">
-              <ma14:wrappingTextBoxFlag xmlns="" xmlns:ma14="http://schemas.microsoft.com/office/mac/drawingml/2011/main" val="0"/>
+              <ma14:wrappingTextBoxFlag xmlns:ma14="http://schemas.microsoft.com/office/mac/drawingml/2011/main" xmlns="" val="0"/>
             </a:ext>
           </a:extLst>
         </p:spPr>
@@ -5519,7 +5582,7 @@
           </a:prstGeom>
           <a:extLst>
             <a:ext uri="{C572A759-6A51-4108-AA02-DFA0A04FC94B}">
-              <ma14:wrappingTextBoxFlag xmlns="" xmlns:ma14="http://schemas.microsoft.com/office/mac/drawingml/2011/main" val="0"/>
+              <ma14:wrappingTextBoxFlag xmlns:ma14="http://schemas.microsoft.com/office/mac/drawingml/2011/main" xmlns="" val="0"/>
             </a:ext>
           </a:extLst>
         </p:spPr>
@@ -6970,7 +7033,7 @@
           </a:prstGeom>
           <a:extLst>
             <a:ext uri="{C572A759-6A51-4108-AA02-DFA0A04FC94B}">
-              <ma14:wrappingTextBoxFlag xmlns="" xmlns:ma14="http://schemas.microsoft.com/office/mac/drawingml/2011/main" val="0"/>
+              <ma14:wrappingTextBoxFlag xmlns:ma14="http://schemas.microsoft.com/office/mac/drawingml/2011/main" xmlns="" val="0"/>
             </a:ext>
           </a:extLst>
         </p:spPr>
@@ -7086,7 +7149,7 @@
           </a:prstGeom>
           <a:extLst>
             <a:ext uri="{C572A759-6A51-4108-AA02-DFA0A04FC94B}">
-              <ma14:wrappingTextBoxFlag xmlns:ma14="http://schemas.microsoft.com/office/mac/drawingml/2011/main" xmlns="" val="0"/>
+              <ma14:wrappingTextBoxFlag xmlns="" xmlns:ma14="http://schemas.microsoft.com/office/mac/drawingml/2011/main" val="0"/>
             </a:ext>
           </a:extLst>
         </p:spPr>
@@ -7971,7 +8034,7 @@
           </a:prstGeom>
           <a:extLst>
             <a:ext uri="{C572A759-6A51-4108-AA02-DFA0A04FC94B}">
-              <ma14:wrappingTextBoxFlag xmlns="" xmlns:ma14="http://schemas.microsoft.com/office/mac/drawingml/2011/main" val="0"/>
+              <ma14:wrappingTextBoxFlag xmlns:ma14="http://schemas.microsoft.com/office/mac/drawingml/2011/main" xmlns="" val="0"/>
             </a:ext>
           </a:extLst>
         </p:spPr>
@@ -9928,7 +9991,7 @@
           </a:prstGeom>
           <a:extLst>
             <a:ext uri="{C572A759-6A51-4108-AA02-DFA0A04FC94B}">
-              <ma14:wrappingTextBoxFlag xmlns="" xmlns:ma14="http://schemas.microsoft.com/office/mac/drawingml/2011/main" val="0"/>
+              <ma14:wrappingTextBoxFlag xmlns:ma14="http://schemas.microsoft.com/office/mac/drawingml/2011/main" xmlns="" val="0"/>
             </a:ext>
           </a:extLst>
         </p:spPr>
@@ -10534,7 +10597,7 @@
           </a:prstGeom>
           <a:extLst>
             <a:ext uri="{C572A759-6A51-4108-AA02-DFA0A04FC94B}">
-              <ma14:wrappingTextBoxFlag xmlns="" xmlns:ma14="http://schemas.microsoft.com/office/mac/drawingml/2011/main" val="0"/>
+              <ma14:wrappingTextBoxFlag xmlns:ma14="http://schemas.microsoft.com/office/mac/drawingml/2011/main" xmlns="" val="0"/>
             </a:ext>
           </a:extLst>
         </p:spPr>
@@ -11996,7 +12059,7 @@
           </a:prstGeom>
           <a:extLst>
             <a:ext uri="{C572A759-6A51-4108-AA02-DFA0A04FC94B}">
-              <ma14:wrappingTextBoxFlag xmlns="" xmlns:ma14="http://schemas.microsoft.com/office/mac/drawingml/2011/main" val="0"/>
+              <ma14:wrappingTextBoxFlag xmlns:ma14="http://schemas.microsoft.com/office/mac/drawingml/2011/main" xmlns="" val="0"/>
             </a:ext>
           </a:extLst>
         </p:spPr>
@@ -14021,7 +14084,7 @@
           </a:prstGeom>
           <a:extLst>
             <a:ext uri="{C572A759-6A51-4108-AA02-DFA0A04FC94B}">
-              <ma14:wrappingTextBoxFlag xmlns="" xmlns:ma14="http://schemas.microsoft.com/office/mac/drawingml/2011/main" val="0"/>
+              <ma14:wrappingTextBoxFlag xmlns:ma14="http://schemas.microsoft.com/office/mac/drawingml/2011/main" xmlns="" val="0"/>
             </a:ext>
           </a:extLst>
         </p:spPr>

</xml_diff>

<commit_message>
Block payments without a PAN; deck and demo script on the new design
- A payment without a PAN is escalated and cannot be signed (rule
  lrs_pan_mandatory, RBI LRS Master Direction para 16); the what-if panel
  still shows the no-PAN cost. Tests for both paths.
- Deck: slide 3 shows the eight steps; slide 4 uses new screenshots of the
  redesigned app; PDF re-exported; test count 249.
- docs/screenshots retaken on the new design; DEMO_SCRIPT rewritten for
  sign-in, the eight steps, the assistant and attack-lab traces.
- Docs and landing page: 249 tests, eight steps, assistant page.
- Logo mark and favicon removed (wordmark only), as decided on 19 Oct.

Co-Authored-By: Claude Opus 5.5 <noreply@anthropic.com>
</commit_message>
<xml_diff>
--- a/docs/presentation/TuitionPilot_deck.pptx
+++ b/docs/presentation/TuitionPilot_deck.pptx
@@ -889,7 +889,7 @@
           <a:p>
             <a:r>
               <a:rPr lang="en-US"/>
-              <a:t>About 45 seconds. Everything here can be rerun with one command each. 248 tests pass. All 27 scenarios pass: ten task-completion, six safe-execution, nine attacks including a forged approval and a revoked university key, and two privacy scenarios. The attack lab stops all 16 attacks. The scripted sandbox run writes a ledger, the log of what the AI saw, and an audit log whose hash chain verifies. A finance audit of 400 random cases matched an independent formula.</a:t>
+              <a:t>About 45 seconds. Everything here can be rerun with one command each. 249 tests pass. All 27 scenarios pass: ten task-completion, six safe-execution, nine attacks including a forged approval and a revoked university key, and two privacy scenarios. The attack lab stops all 16 attacks. The scripted sandbox run writes a ledger, the log of what the AI saw, and an audit log whose hash chain verifies. A finance audit of 400 random cases matched an independent formula.</a:t>
             </a:r>
             <a:endParaRPr lang="en-US" dirty="0"/>
           </a:p>
@@ -1153,7 +1153,7 @@
           <a:p>
             <a:r>
               <a:rPr lang="en-US"/>
-              <a:t>About 50 seconds. The app tells the payment as a guided six-step story: consent, the invoice with an animated signature check, one question at a time, the best route with a cost chart and what-if sliders, review and sign with a PIN while the parent's device signs the plan, and the receipt. Beside it, a live agent panel shows the next action and why, every decision, and exactly what the AI saw. Code computes and the AI explains: it runs offline by default, and a hosted Claude model can be switched on behind the same guards.</a:t>
+              <a:t>About 50 seconds. The app walks the family through eight steps, shown as a bar across the top: consent, upload the invoice, the signature check, one question at a time, the best route with a cost chart and what-if sliders, the A2-style draft with the RBI compliance checks, review and sign with a PIN while the parent's device signs the plan, and a printable receipt. Beside it, a live agent panel shows the next action and why, every decision, the rule trace and exactly what the AI saw; it can be hidden. An Assistant page answers questions from the rules engine. Code computes and the AI explains: it runs offline by default, and a hosted Claude model can be switched on behind the same guards.</a:t>
             </a:r>
             <a:endParaRPr lang="en-US" dirty="0"/>
           </a:p>
@@ -2434,6 +2434,13 @@
           </a:solidFill>
           <a:ln/>
         </p:spPr>
+        <p:txBody>
+          <a:bodyPr/>
+          <a:lstStyle/>
+          <a:p>
+            <a:endParaRPr lang="en-IN"/>
+          </a:p>
+        </p:txBody>
       </p:sp>
       <p:sp>
         <p:nvSpPr>
@@ -2454,6 +2461,13 @@
           </a:solidFill>
           <a:ln/>
         </p:spPr>
+        <p:txBody>
+          <a:bodyPr/>
+          <a:lstStyle/>
+          <a:p>
+            <a:endParaRPr lang="en-IN"/>
+          </a:p>
+        </p:txBody>
       </p:sp>
       <p:sp>
         <p:nvSpPr>
@@ -2554,6 +2568,13 @@
           </a:solidFill>
           <a:ln/>
         </p:spPr>
+        <p:txBody>
+          <a:bodyPr/>
+          <a:lstStyle/>
+          <a:p>
+            <a:endParaRPr lang="en-IN"/>
+          </a:p>
+        </p:txBody>
       </p:sp>
       <p:sp>
         <p:nvSpPr>
@@ -2574,6 +2595,13 @@
           </a:solidFill>
           <a:ln/>
         </p:spPr>
+        <p:txBody>
+          <a:bodyPr/>
+          <a:lstStyle/>
+          <a:p>
+            <a:endParaRPr lang="en-IN"/>
+          </a:p>
+        </p:txBody>
       </p:sp>
       <p:sp>
         <p:nvSpPr>
@@ -2674,6 +2702,13 @@
           </a:solidFill>
           <a:ln/>
         </p:spPr>
+        <p:txBody>
+          <a:bodyPr/>
+          <a:lstStyle/>
+          <a:p>
+            <a:endParaRPr lang="en-IN"/>
+          </a:p>
+        </p:txBody>
       </p:sp>
       <p:sp>
         <p:nvSpPr>
@@ -2694,6 +2729,13 @@
           </a:solidFill>
           <a:ln/>
         </p:spPr>
+        <p:txBody>
+          <a:bodyPr/>
+          <a:lstStyle/>
+          <a:p>
+            <a:endParaRPr lang="en-IN"/>
+          </a:p>
+        </p:txBody>
       </p:sp>
       <p:sp>
         <p:nvSpPr>
@@ -2938,7 +2980,7 @@
                 <a:ea typeface="Cambria" pitchFamily="34" charset="-122"/>
                 <a:cs typeface="Cambria" pitchFamily="34" charset="-120"/>
               </a:rPr>
-              <a:t>248</a:t>
+              <a:t>249</a:t>
             </a:r>
             <a:endParaRPr lang="en-US" sz="4400" dirty="0"/>
           </a:p>
@@ -4120,6 +4162,13 @@
             <a:prstDash val="solid"/>
           </a:ln>
         </p:spPr>
+        <p:txBody>
+          <a:bodyPr/>
+          <a:lstStyle/>
+          <a:p>
+            <a:endParaRPr lang="en-IN"/>
+          </a:p>
+        </p:txBody>
       </p:sp>
       <p:sp>
         <p:nvSpPr>
@@ -4264,6 +4313,13 @@
           </a:solidFill>
           <a:ln/>
         </p:spPr>
+        <p:txBody>
+          <a:bodyPr/>
+          <a:lstStyle/>
+          <a:p>
+            <a:endParaRPr lang="en-IN"/>
+          </a:p>
+        </p:txBody>
       </p:sp>
       <p:sp>
         <p:nvSpPr>
@@ -4428,6 +4484,13 @@
           </a:solidFill>
           <a:ln/>
         </p:spPr>
+        <p:txBody>
+          <a:bodyPr/>
+          <a:lstStyle/>
+          <a:p>
+            <a:endParaRPr lang="en-IN"/>
+          </a:p>
+        </p:txBody>
       </p:sp>
       <p:sp>
         <p:nvSpPr>
@@ -4592,6 +4655,13 @@
           </a:solidFill>
           <a:ln/>
         </p:spPr>
+        <p:txBody>
+          <a:bodyPr/>
+          <a:lstStyle/>
+          <a:p>
+            <a:endParaRPr lang="en-IN"/>
+          </a:p>
+        </p:txBody>
       </p:sp>
       <p:sp>
         <p:nvSpPr>
@@ -4769,6 +4839,13 @@
           </a:solidFill>
           <a:ln/>
         </p:spPr>
+        <p:txBody>
+          <a:bodyPr/>
+          <a:lstStyle/>
+          <a:p>
+            <a:endParaRPr lang="en-IN"/>
+          </a:p>
+        </p:txBody>
       </p:sp>
       <p:sp>
         <p:nvSpPr>
@@ -4789,6 +4866,13 @@
           </a:solidFill>
           <a:ln/>
         </p:spPr>
+        <p:txBody>
+          <a:bodyPr/>
+          <a:lstStyle/>
+          <a:p>
+            <a:endParaRPr lang="en-IN"/>
+          </a:p>
+        </p:txBody>
       </p:sp>
       <p:sp>
         <p:nvSpPr>
@@ -4928,6 +5012,13 @@
           </a:solidFill>
           <a:ln/>
         </p:spPr>
+        <p:txBody>
+          <a:bodyPr/>
+          <a:lstStyle/>
+          <a:p>
+            <a:endParaRPr lang="en-IN"/>
+          </a:p>
+        </p:txBody>
       </p:sp>
       <p:sp>
         <p:nvSpPr>
@@ -4948,6 +5039,13 @@
           </a:solidFill>
           <a:ln/>
         </p:spPr>
+        <p:txBody>
+          <a:bodyPr/>
+          <a:lstStyle/>
+          <a:p>
+            <a:endParaRPr lang="en-IN"/>
+          </a:p>
+        </p:txBody>
       </p:sp>
       <p:sp>
         <p:nvSpPr>
@@ -5087,6 +5185,13 @@
           </a:solidFill>
           <a:ln/>
         </p:spPr>
+        <p:txBody>
+          <a:bodyPr/>
+          <a:lstStyle/>
+          <a:p>
+            <a:endParaRPr lang="en-IN"/>
+          </a:p>
+        </p:txBody>
       </p:sp>
       <p:sp>
         <p:nvSpPr>
@@ -5107,6 +5212,13 @@
           </a:solidFill>
           <a:ln/>
         </p:spPr>
+        <p:txBody>
+          <a:bodyPr/>
+          <a:lstStyle/>
+          <a:p>
+            <a:endParaRPr lang="en-IN"/>
+          </a:p>
+        </p:txBody>
       </p:sp>
       <p:sp>
         <p:nvSpPr>
@@ -5246,6 +5358,13 @@
           </a:solidFill>
           <a:ln/>
         </p:spPr>
+        <p:txBody>
+          <a:bodyPr/>
+          <a:lstStyle/>
+          <a:p>
+            <a:endParaRPr lang="en-IN"/>
+          </a:p>
+        </p:txBody>
       </p:sp>
       <p:sp>
         <p:nvSpPr>
@@ -5266,6 +5385,13 @@
           </a:solidFill>
           <a:ln/>
         </p:spPr>
+        <p:txBody>
+          <a:bodyPr/>
+          <a:lstStyle/>
+          <a:p>
+            <a:endParaRPr lang="en-IN"/>
+          </a:p>
+        </p:txBody>
       </p:sp>
       <p:sp>
         <p:nvSpPr>
@@ -5405,6 +5531,13 @@
           </a:solidFill>
           <a:ln/>
         </p:spPr>
+        <p:txBody>
+          <a:bodyPr/>
+          <a:lstStyle/>
+          <a:p>
+            <a:endParaRPr lang="en-IN"/>
+          </a:p>
+        </p:txBody>
       </p:sp>
       <p:sp>
         <p:nvSpPr>
@@ -5664,7 +5797,7 @@
               <a:buNone/>
             </a:pPr>
             <a:r>
-              <a:rPr lang="en-US" sz="3000" b="1" dirty="0">
+              <a:rPr lang="en-US" sz="3000" b="1">
                 <a:solidFill>
                   <a:srgbClr val="14213D"/>
                 </a:solidFill>
@@ -5672,7 +5805,7 @@
                 <a:ea typeface="Cambria" pitchFamily="34" charset="-122"/>
                 <a:cs typeface="Cambria" pitchFamily="34" charset="-120"/>
               </a:rPr>
-              <a:t>One guided flow, from invoice to receipt</a:t>
+              <a:t>Eight guided steps, from invoice to receipt</a:t>
             </a:r>
             <a:endParaRPr lang="en-US" sz="3000" dirty="0"/>
           </a:p>
@@ -5686,8 +5819,8 @@
         </p:nvSpPr>
         <p:spPr>
           <a:xfrm>
-            <a:off x="548640" y="1371600"/>
-            <a:ext cx="1719072" cy="2331720"/>
+            <a:off x="546100" y="1371600"/>
+            <a:ext cx="1244600" cy="2331720"/>
           </a:xfrm>
           <a:prstGeom prst="roundRect">
             <a:avLst>
@@ -5699,6 +5832,13 @@
           </a:solidFill>
           <a:ln/>
         </p:spPr>
+        <p:txBody>
+          <a:bodyPr/>
+          <a:lstStyle/>
+          <a:p>
+            <a:endParaRPr lang="en-IN"/>
+          </a:p>
+        </p:txBody>
       </p:sp>
       <p:sp>
         <p:nvSpPr>
@@ -5708,7 +5848,7 @@
         </p:nvSpPr>
         <p:spPr>
           <a:xfrm>
-            <a:off x="749808" y="1572768"/>
+            <a:off x="698500" y="1572768"/>
             <a:ext cx="502920" cy="502920"/>
           </a:xfrm>
           <a:prstGeom prst="ellipse">
@@ -5719,6 +5859,13 @@
           </a:solidFill>
           <a:ln/>
         </p:spPr>
+        <p:txBody>
+          <a:bodyPr/>
+          <a:lstStyle/>
+          <a:p>
+            <a:endParaRPr lang="en-IN"/>
+          </a:p>
+        </p:txBody>
       </p:sp>
       <p:sp>
         <p:nvSpPr>
@@ -5728,7 +5875,7 @@
         </p:nvSpPr>
         <p:spPr>
           <a:xfrm>
-            <a:off x="749808" y="1572768"/>
+            <a:off x="698500" y="1572768"/>
             <a:ext cx="502920" cy="502920"/>
           </a:xfrm>
           <a:prstGeom prst="rect">
@@ -5745,7 +5892,7 @@
               <a:buNone/>
             </a:pPr>
             <a:r>
-              <a:rPr lang="en-US" sz="1800" b="1" dirty="0">
+              <a:rPr lang="en-US" sz="1800" b="1">
                 <a:solidFill>
                   <a:srgbClr val="FFFFFF"/>
                 </a:solidFill>
@@ -5767,8 +5914,8 @@
         </p:nvSpPr>
         <p:spPr>
           <a:xfrm>
-            <a:off x="749808" y="2194560"/>
-            <a:ext cx="1371600" cy="365760"/>
+            <a:off x="647700" y="2194560"/>
+            <a:ext cx="1041400" cy="381000"/>
           </a:xfrm>
           <a:prstGeom prst="rect">
             <a:avLst/>
@@ -5784,7 +5931,7 @@
               <a:buNone/>
             </a:pPr>
             <a:r>
-              <a:rPr lang="en-US" sz="1600" b="1" dirty="0">
+              <a:rPr lang="en-US" sz="1100" b="1">
                 <a:solidFill>
                   <a:srgbClr val="14213D"/>
                 </a:solidFill>
@@ -5792,9 +5939,9 @@
                 <a:ea typeface="Calibri" pitchFamily="34" charset="-122"/>
                 <a:cs typeface="Calibri" pitchFamily="34" charset="-120"/>
               </a:rPr>
-              <a:t>Welcome</a:t>
-            </a:r>
-            <a:endParaRPr lang="en-US" sz="1600" dirty="0"/>
+              <a:t>Consent</a:t>
+            </a:r>
+            <a:endParaRPr lang="en-US" sz="1100" dirty="0"/>
           </a:p>
         </p:txBody>
       </p:sp>
@@ -5806,8 +5953,8 @@
         </p:nvSpPr>
         <p:spPr>
           <a:xfrm>
-            <a:off x="749808" y="2606040"/>
-            <a:ext cx="1371600" cy="1005840"/>
+            <a:off x="647700" y="2628900"/>
+            <a:ext cx="1041400" cy="1005840"/>
           </a:xfrm>
           <a:prstGeom prst="rect">
             <a:avLst/>
@@ -5823,7 +5970,7 @@
               <a:buNone/>
             </a:pPr>
             <a:r>
-              <a:rPr lang="en-US" sz="1300" dirty="0">
+              <a:rPr lang="en-US" sz="950">
                 <a:solidFill>
                   <a:srgbClr val="5A6378"/>
                 </a:solidFill>
@@ -5833,7 +5980,7 @@
               </a:rPr>
               <a:t>Two consents before any data is read</a:t>
             </a:r>
-            <a:endParaRPr lang="en-US" sz="1300" dirty="0"/>
+            <a:endParaRPr lang="en-US" sz="950" dirty="0"/>
           </a:p>
         </p:txBody>
       </p:sp>
@@ -5845,8 +5992,8 @@
         </p:nvSpPr>
         <p:spPr>
           <a:xfrm>
-            <a:off x="2423160" y="1371600"/>
-            <a:ext cx="1719072" cy="2331720"/>
+            <a:off x="1948543" y="1371600"/>
+            <a:ext cx="1244600" cy="2331720"/>
           </a:xfrm>
           <a:prstGeom prst="roundRect">
             <a:avLst>
@@ -5858,6 +6005,13 @@
           </a:solidFill>
           <a:ln/>
         </p:spPr>
+        <p:txBody>
+          <a:bodyPr/>
+          <a:lstStyle/>
+          <a:p>
+            <a:endParaRPr lang="en-IN"/>
+          </a:p>
+        </p:txBody>
       </p:sp>
       <p:sp>
         <p:nvSpPr>
@@ -5867,7 +6021,7 @@
         </p:nvSpPr>
         <p:spPr>
           <a:xfrm>
-            <a:off x="2624328" y="1572768"/>
+            <a:off x="2100943" y="1572768"/>
             <a:ext cx="502920" cy="502920"/>
           </a:xfrm>
           <a:prstGeom prst="ellipse">
@@ -5878,6 +6032,13 @@
           </a:solidFill>
           <a:ln/>
         </p:spPr>
+        <p:txBody>
+          <a:bodyPr/>
+          <a:lstStyle/>
+          <a:p>
+            <a:endParaRPr lang="en-IN"/>
+          </a:p>
+        </p:txBody>
       </p:sp>
       <p:sp>
         <p:nvSpPr>
@@ -5887,7 +6048,7 @@
         </p:nvSpPr>
         <p:spPr>
           <a:xfrm>
-            <a:off x="2624328" y="1572768"/>
+            <a:off x="2100943" y="1572768"/>
             <a:ext cx="502920" cy="502920"/>
           </a:xfrm>
           <a:prstGeom prst="rect">
@@ -5904,7 +6065,7 @@
               <a:buNone/>
             </a:pPr>
             <a:r>
-              <a:rPr lang="en-US" sz="1800" b="1" dirty="0">
+              <a:rPr lang="en-US" sz="1800" b="1">
                 <a:solidFill>
                   <a:srgbClr val="FFFFFF"/>
                 </a:solidFill>
@@ -5926,8 +6087,8 @@
         </p:nvSpPr>
         <p:spPr>
           <a:xfrm>
-            <a:off x="2624328" y="2194560"/>
-            <a:ext cx="1371600" cy="365760"/>
+            <a:off x="2050143" y="2194560"/>
+            <a:ext cx="1041400" cy="381000"/>
           </a:xfrm>
           <a:prstGeom prst="rect">
             <a:avLst/>
@@ -5943,7 +6104,7 @@
               <a:buNone/>
             </a:pPr>
             <a:r>
-              <a:rPr lang="en-US" sz="1600" b="1" dirty="0">
+              <a:rPr lang="en-US" sz="1100" b="1">
                 <a:solidFill>
                   <a:srgbClr val="14213D"/>
                 </a:solidFill>
@@ -5951,9 +6112,9 @@
                 <a:ea typeface="Calibri" pitchFamily="34" charset="-122"/>
                 <a:cs typeface="Calibri" pitchFamily="34" charset="-120"/>
               </a:rPr>
-              <a:t>Invoice</a:t>
-            </a:r>
-            <a:endParaRPr lang="en-US" sz="1600" dirty="0"/>
+              <a:t>Upload invoice</a:t>
+            </a:r>
+            <a:endParaRPr lang="en-US" sz="1100" dirty="0"/>
           </a:p>
         </p:txBody>
       </p:sp>
@@ -5965,8 +6126,8 @@
         </p:nvSpPr>
         <p:spPr>
           <a:xfrm>
-            <a:off x="2624328" y="2606040"/>
-            <a:ext cx="1371600" cy="1005840"/>
+            <a:off x="2050143" y="2628900"/>
+            <a:ext cx="1041400" cy="1005840"/>
           </a:xfrm>
           <a:prstGeom prst="rect">
             <a:avLst/>
@@ -5982,7 +6143,7 @@
               <a:buNone/>
             </a:pPr>
             <a:r>
-              <a:rPr lang="en-US" sz="1300" dirty="0">
+              <a:rPr lang="en-US" sz="950">
                 <a:solidFill>
                   <a:srgbClr val="5A6378"/>
                 </a:solidFill>
@@ -5990,9 +6151,9 @@
                 <a:ea typeface="Calibri" pitchFamily="34" charset="-122"/>
                 <a:cs typeface="Calibri" pitchFamily="34" charset="-120"/>
               </a:rPr>
-              <a:t>Animated check of the university’s signature chain</a:t>
-            </a:r>
-            <a:endParaRPr lang="en-US" sz="1300" dirty="0"/>
+              <a:t>PDF, JSON or pasted text; masked first</a:t>
+            </a:r>
+            <a:endParaRPr lang="en-US" sz="950" dirty="0"/>
           </a:p>
         </p:txBody>
       </p:sp>
@@ -6004,8 +6165,8 @@
         </p:nvSpPr>
         <p:spPr>
           <a:xfrm>
-            <a:off x="4297680" y="1371600"/>
-            <a:ext cx="1719072" cy="2331720"/>
+            <a:off x="3350986" y="1371600"/>
+            <a:ext cx="1244600" cy="2331720"/>
           </a:xfrm>
           <a:prstGeom prst="roundRect">
             <a:avLst>
@@ -6017,6 +6178,13 @@
           </a:solidFill>
           <a:ln/>
         </p:spPr>
+        <p:txBody>
+          <a:bodyPr/>
+          <a:lstStyle/>
+          <a:p>
+            <a:endParaRPr lang="en-IN"/>
+          </a:p>
+        </p:txBody>
       </p:sp>
       <p:sp>
         <p:nvSpPr>
@@ -6026,7 +6194,7 @@
         </p:nvSpPr>
         <p:spPr>
           <a:xfrm>
-            <a:off x="4498848" y="1572768"/>
+            <a:off x="3503386" y="1572768"/>
             <a:ext cx="502920" cy="502920"/>
           </a:xfrm>
           <a:prstGeom prst="ellipse">
@@ -6037,6 +6205,13 @@
           </a:solidFill>
           <a:ln/>
         </p:spPr>
+        <p:txBody>
+          <a:bodyPr/>
+          <a:lstStyle/>
+          <a:p>
+            <a:endParaRPr lang="en-IN"/>
+          </a:p>
+        </p:txBody>
       </p:sp>
       <p:sp>
         <p:nvSpPr>
@@ -6046,7 +6221,7 @@
         </p:nvSpPr>
         <p:spPr>
           <a:xfrm>
-            <a:off x="4498848" y="1572768"/>
+            <a:off x="3503386" y="1572768"/>
             <a:ext cx="502920" cy="502920"/>
           </a:xfrm>
           <a:prstGeom prst="rect">
@@ -6063,7 +6238,7 @@
               <a:buNone/>
             </a:pPr>
             <a:r>
-              <a:rPr lang="en-US" sz="1800" b="1" dirty="0">
+              <a:rPr lang="en-US" sz="1800" b="1">
                 <a:solidFill>
                   <a:srgbClr val="FFFFFF"/>
                 </a:solidFill>
@@ -6085,8 +6260,8 @@
         </p:nvSpPr>
         <p:spPr>
           <a:xfrm>
-            <a:off x="4498848" y="2194560"/>
-            <a:ext cx="1371600" cy="365760"/>
+            <a:off x="3452586" y="2194560"/>
+            <a:ext cx="1041400" cy="381000"/>
           </a:xfrm>
           <a:prstGeom prst="rect">
             <a:avLst/>
@@ -6102,7 +6277,7 @@
               <a:buNone/>
             </a:pPr>
             <a:r>
-              <a:rPr lang="en-US" sz="1600" b="1" dirty="0">
+              <a:rPr lang="en-US" sz="1100" b="1">
                 <a:solidFill>
                   <a:srgbClr val="14213D"/>
                 </a:solidFill>
@@ -6110,9 +6285,9 @@
                 <a:ea typeface="Calibri" pitchFamily="34" charset="-122"/>
                 <a:cs typeface="Calibri" pitchFamily="34" charset="-120"/>
               </a:rPr>
-              <a:t>Questions</a:t>
-            </a:r>
-            <a:endParaRPr lang="en-US" sz="1600" dirty="0"/>
+              <a:t>Verify signature</a:t>
+            </a:r>
+            <a:endParaRPr lang="en-US" sz="1100" dirty="0"/>
           </a:p>
         </p:txBody>
       </p:sp>
@@ -6124,8 +6299,8 @@
         </p:nvSpPr>
         <p:spPr>
           <a:xfrm>
-            <a:off x="4498848" y="2606040"/>
-            <a:ext cx="1371600" cy="1005840"/>
+            <a:off x="3452586" y="2628900"/>
+            <a:ext cx="1041400" cy="1005840"/>
           </a:xfrm>
           <a:prstGeom prst="rect">
             <a:avLst/>
@@ -6141,7 +6316,7 @@
               <a:buNone/>
             </a:pPr>
             <a:r>
-              <a:rPr lang="en-US" sz="1300" dirty="0">
+              <a:rPr lang="en-US" sz="950">
                 <a:solidFill>
                   <a:srgbClr val="5A6378"/>
                 </a:solidFill>
@@ -6149,9 +6324,9 @@
                 <a:ea typeface="Calibri" pitchFamily="34" charset="-122"/>
                 <a:cs typeface="Calibri" pitchFamily="34" charset="-120"/>
               </a:rPr>
-              <a:t>One at a time; the agent asks, never guesses</a:t>
-            </a:r>
-            <a:endParaRPr lang="en-US" sz="1300" dirty="0"/>
+              <a:t>Root, certificate and invoice, link by link</a:t>
+            </a:r>
+            <a:endParaRPr lang="en-US" sz="950" dirty="0"/>
           </a:p>
         </p:txBody>
       </p:sp>
@@ -6163,8 +6338,8 @@
         </p:nvSpPr>
         <p:spPr>
           <a:xfrm>
-            <a:off x="6172200" y="1371600"/>
-            <a:ext cx="1719072" cy="2331720"/>
+            <a:off x="4753428" y="1371600"/>
+            <a:ext cx="1244600" cy="2331720"/>
           </a:xfrm>
           <a:prstGeom prst="roundRect">
             <a:avLst>
@@ -6176,6 +6351,13 @@
           </a:solidFill>
           <a:ln/>
         </p:spPr>
+        <p:txBody>
+          <a:bodyPr/>
+          <a:lstStyle/>
+          <a:p>
+            <a:endParaRPr lang="en-IN"/>
+          </a:p>
+        </p:txBody>
       </p:sp>
       <p:sp>
         <p:nvSpPr>
@@ -6185,7 +6367,7 @@
         </p:nvSpPr>
         <p:spPr>
           <a:xfrm>
-            <a:off x="6373368" y="1572768"/>
+            <a:off x="4905828" y="1572768"/>
             <a:ext cx="502920" cy="502920"/>
           </a:xfrm>
           <a:prstGeom prst="ellipse">
@@ -6196,6 +6378,13 @@
           </a:solidFill>
           <a:ln/>
         </p:spPr>
+        <p:txBody>
+          <a:bodyPr/>
+          <a:lstStyle/>
+          <a:p>
+            <a:endParaRPr lang="en-IN"/>
+          </a:p>
+        </p:txBody>
       </p:sp>
       <p:sp>
         <p:nvSpPr>
@@ -6205,7 +6394,7 @@
         </p:nvSpPr>
         <p:spPr>
           <a:xfrm>
-            <a:off x="6373368" y="1572768"/>
+            <a:off x="4905828" y="1572768"/>
             <a:ext cx="502920" cy="502920"/>
           </a:xfrm>
           <a:prstGeom prst="rect">
@@ -6222,7 +6411,7 @@
               <a:buNone/>
             </a:pPr>
             <a:r>
-              <a:rPr lang="en-US" sz="1800" b="1" dirty="0">
+              <a:rPr lang="en-US" sz="1800" b="1">
                 <a:solidFill>
                   <a:srgbClr val="FFFFFF"/>
                 </a:solidFill>
@@ -6244,8 +6433,8 @@
         </p:nvSpPr>
         <p:spPr>
           <a:xfrm>
-            <a:off x="6373368" y="2194560"/>
-            <a:ext cx="1371600" cy="365760"/>
+            <a:off x="4855028" y="2194560"/>
+            <a:ext cx="1041400" cy="381000"/>
           </a:xfrm>
           <a:prstGeom prst="rect">
             <a:avLst/>
@@ -6261,7 +6450,7 @@
               <a:buNone/>
             </a:pPr>
             <a:r>
-              <a:rPr lang="en-US" sz="1600" b="1" dirty="0">
+              <a:rPr lang="en-US" sz="1100" b="1">
                 <a:solidFill>
                   <a:srgbClr val="14213D"/>
                 </a:solidFill>
@@ -6269,9 +6458,9 @@
                 <a:ea typeface="Calibri" pitchFamily="34" charset="-122"/>
                 <a:cs typeface="Calibri" pitchFamily="34" charset="-120"/>
               </a:rPr>
-              <a:t>Best route</a:t>
-            </a:r>
-            <a:endParaRPr lang="en-US" sz="1600" dirty="0"/>
+              <a:t>Questions</a:t>
+            </a:r>
+            <a:endParaRPr lang="en-US" sz="1100" dirty="0"/>
           </a:p>
         </p:txBody>
       </p:sp>
@@ -6283,8 +6472,8 @@
         </p:nvSpPr>
         <p:spPr>
           <a:xfrm>
-            <a:off x="6373368" y="2606040"/>
-            <a:ext cx="1371600" cy="1005840"/>
+            <a:off x="4855028" y="2628900"/>
+            <a:ext cx="1041400" cy="1005840"/>
           </a:xfrm>
           <a:prstGeom prst="rect">
             <a:avLst/>
@@ -6300,7 +6489,7 @@
               <a:buNone/>
             </a:pPr>
             <a:r>
-              <a:rPr lang="en-US" sz="1300" dirty="0">
+              <a:rPr lang="en-US" sz="950">
                 <a:solidFill>
                   <a:srgbClr val="5A6378"/>
                 </a:solidFill>
@@ -6308,9 +6497,9 @@
                 <a:ea typeface="Calibri" pitchFamily="34" charset="-122"/>
                 <a:cs typeface="Calibri" pitchFamily="34" charset="-120"/>
               </a:rPr>
-              <a:t>Cost chart, what-if sliders, LRS limit gauge</a:t>
-            </a:r>
-            <a:endParaRPr lang="en-US" sz="1300" dirty="0"/>
+              <a:t>One at a time; asks, never guesses</a:t>
+            </a:r>
+            <a:endParaRPr lang="en-US" sz="950" dirty="0"/>
           </a:p>
         </p:txBody>
       </p:sp>
@@ -6322,8 +6511,8 @@
         </p:nvSpPr>
         <p:spPr>
           <a:xfrm>
-            <a:off x="8046720" y="1371600"/>
-            <a:ext cx="1719072" cy="2331720"/>
+            <a:off x="6155872" y="1371600"/>
+            <a:ext cx="1244600" cy="2331720"/>
           </a:xfrm>
           <a:prstGeom prst="roundRect">
             <a:avLst>
@@ -6340,6 +6529,13 @@
             <a:prstDash val="solid"/>
           </a:ln>
         </p:spPr>
+        <p:txBody>
+          <a:bodyPr/>
+          <a:lstStyle/>
+          <a:p>
+            <a:endParaRPr lang="en-IN"/>
+          </a:p>
+        </p:txBody>
       </p:sp>
       <p:sp>
         <p:nvSpPr>
@@ -6349,7 +6545,7 @@
         </p:nvSpPr>
         <p:spPr>
           <a:xfrm>
-            <a:off x="8247888" y="1572768"/>
+            <a:off x="6308272" y="1572768"/>
             <a:ext cx="502920" cy="502920"/>
           </a:xfrm>
           <a:prstGeom prst="ellipse">
@@ -6360,6 +6556,13 @@
           </a:solidFill>
           <a:ln/>
         </p:spPr>
+        <p:txBody>
+          <a:bodyPr/>
+          <a:lstStyle/>
+          <a:p>
+            <a:endParaRPr lang="en-IN"/>
+          </a:p>
+        </p:txBody>
       </p:sp>
       <p:sp>
         <p:nvSpPr>
@@ -6369,7 +6572,7 @@
         </p:nvSpPr>
         <p:spPr>
           <a:xfrm>
-            <a:off x="8247888" y="1572768"/>
+            <a:off x="6308272" y="1572768"/>
             <a:ext cx="502920" cy="502920"/>
           </a:xfrm>
           <a:prstGeom prst="rect">
@@ -6386,7 +6589,7 @@
               <a:buNone/>
             </a:pPr>
             <a:r>
-              <a:rPr lang="en-US" sz="1800" b="1" dirty="0">
+              <a:rPr lang="en-US" sz="1800" b="1">
                 <a:solidFill>
                   <a:srgbClr val="FFFFFF"/>
                 </a:solidFill>
@@ -6408,8 +6611,8 @@
         </p:nvSpPr>
         <p:spPr>
           <a:xfrm>
-            <a:off x="8247888" y="2194560"/>
-            <a:ext cx="1371600" cy="365760"/>
+            <a:off x="6257472" y="2194560"/>
+            <a:ext cx="1041400" cy="381000"/>
           </a:xfrm>
           <a:prstGeom prst="rect">
             <a:avLst/>
@@ -6425,7 +6628,7 @@
               <a:buNone/>
             </a:pPr>
             <a:r>
-              <a:rPr lang="en-US" sz="1600" b="1" dirty="0">
+              <a:rPr lang="en-US" sz="1100" b="1">
                 <a:solidFill>
                   <a:srgbClr val="14213D"/>
                 </a:solidFill>
@@ -6433,9 +6636,9 @@
                 <a:ea typeface="Calibri" pitchFamily="34" charset="-122"/>
                 <a:cs typeface="Calibri" pitchFamily="34" charset="-120"/>
               </a:rPr>
-              <a:t>Review &amp; sign</a:t>
-            </a:r>
-            <a:endParaRPr lang="en-US" sz="1600" dirty="0"/>
+              <a:t>Compare routes</a:t>
+            </a:r>
+            <a:endParaRPr lang="en-US" sz="1100" dirty="0"/>
           </a:p>
         </p:txBody>
       </p:sp>
@@ -6447,8 +6650,8 @@
         </p:nvSpPr>
         <p:spPr>
           <a:xfrm>
-            <a:off x="8247888" y="2606040"/>
-            <a:ext cx="1371600" cy="1005840"/>
+            <a:off x="6257472" y="2628900"/>
+            <a:ext cx="1041400" cy="1005840"/>
           </a:xfrm>
           <a:prstGeom prst="rect">
             <a:avLst/>
@@ -6464,7 +6667,7 @@
               <a:buNone/>
             </a:pPr>
             <a:r>
-              <a:rPr lang="en-US" sz="1300" dirty="0">
+              <a:rPr lang="en-US" sz="950">
                 <a:solidFill>
                   <a:srgbClr val="5A6378"/>
                 </a:solidFill>
@@ -6472,9 +6675,9 @@
                 <a:ea typeface="Calibri" pitchFamily="34" charset="-122"/>
                 <a:cs typeface="Calibri" pitchFamily="34" charset="-120"/>
               </a:rPr>
-              <a:t>PIN pad; the parent’s device signs the plan</a:t>
-            </a:r>
-            <a:endParaRPr lang="en-US" sz="1300" dirty="0"/>
+              <a:t>Cost chart, what-if sliders, LRS gauge</a:t>
+            </a:r>
+            <a:endParaRPr lang="en-US" sz="950" dirty="0"/>
           </a:p>
         </p:txBody>
       </p:sp>
@@ -6486,8 +6689,8 @@
         </p:nvSpPr>
         <p:spPr>
           <a:xfrm>
-            <a:off x="9921240" y="1371600"/>
-            <a:ext cx="1719072" cy="2331720"/>
+            <a:off x="7558315" y="1371600"/>
+            <a:ext cx="1244600" cy="2331720"/>
           </a:xfrm>
           <a:prstGeom prst="roundRect">
             <a:avLst>
@@ -6499,6 +6702,13 @@
           </a:solidFill>
           <a:ln/>
         </p:spPr>
+        <p:txBody>
+          <a:bodyPr/>
+          <a:lstStyle/>
+          <a:p>
+            <a:endParaRPr lang="en-IN"/>
+          </a:p>
+        </p:txBody>
       </p:sp>
       <p:sp>
         <p:nvSpPr>
@@ -6508,7 +6718,7 @@
         </p:nvSpPr>
         <p:spPr>
           <a:xfrm>
-            <a:off x="10122408" y="1572768"/>
+            <a:off x="7710715" y="1572768"/>
             <a:ext cx="502920" cy="502920"/>
           </a:xfrm>
           <a:prstGeom prst="ellipse">
@@ -6519,6 +6729,13 @@
           </a:solidFill>
           <a:ln/>
         </p:spPr>
+        <p:txBody>
+          <a:bodyPr/>
+          <a:lstStyle/>
+          <a:p>
+            <a:endParaRPr lang="en-IN"/>
+          </a:p>
+        </p:txBody>
       </p:sp>
       <p:sp>
         <p:nvSpPr>
@@ -6528,7 +6745,7 @@
         </p:nvSpPr>
         <p:spPr>
           <a:xfrm>
-            <a:off x="10122408" y="1572768"/>
+            <a:off x="7710715" y="1572768"/>
             <a:ext cx="502920" cy="502920"/>
           </a:xfrm>
           <a:prstGeom prst="rect">
@@ -6545,7 +6762,7 @@
               <a:buNone/>
             </a:pPr>
             <a:r>
-              <a:rPr lang="en-US" sz="1800" b="1" dirty="0">
+              <a:rPr lang="en-US" sz="1800" b="1">
                 <a:solidFill>
                   <a:srgbClr val="FFFFFF"/>
                 </a:solidFill>
@@ -6567,8 +6784,8 @@
         </p:nvSpPr>
         <p:spPr>
           <a:xfrm>
-            <a:off x="10122408" y="2194560"/>
-            <a:ext cx="1371600" cy="365760"/>
+            <a:off x="7659915" y="2194560"/>
+            <a:ext cx="1041400" cy="381000"/>
           </a:xfrm>
           <a:prstGeom prst="rect">
             <a:avLst/>
@@ -6584,7 +6801,7 @@
               <a:buNone/>
             </a:pPr>
             <a:r>
-              <a:rPr lang="en-US" sz="1600" b="1" dirty="0">
+              <a:rPr lang="en-US" sz="1100" b="1">
                 <a:solidFill>
                   <a:srgbClr val="14213D"/>
                 </a:solidFill>
@@ -6592,9 +6809,9 @@
                 <a:ea typeface="Calibri" pitchFamily="34" charset="-122"/>
                 <a:cs typeface="Calibri" pitchFamily="34" charset="-120"/>
               </a:rPr>
-              <a:t>Receipt</a:t>
-            </a:r>
-            <a:endParaRPr lang="en-US" sz="1600" dirty="0"/>
+              <a:t>Documents &amp; A2</a:t>
+            </a:r>
+            <a:endParaRPr lang="en-US" sz="1100" dirty="0"/>
           </a:p>
         </p:txBody>
       </p:sp>
@@ -6606,8 +6823,8 @@
         </p:nvSpPr>
         <p:spPr>
           <a:xfrm>
-            <a:off x="10122408" y="2606040"/>
-            <a:ext cx="1371600" cy="1005840"/>
+            <a:off x="7659915" y="2628900"/>
+            <a:ext cx="1041400" cy="1005840"/>
           </a:xfrm>
           <a:prstGeom prst="rect">
             <a:avLst/>
@@ -6623,7 +6840,7 @@
               <a:buNone/>
             </a:pPr>
             <a:r>
-              <a:rPr lang="en-US" sz="1300" dirty="0">
+              <a:rPr lang="en-US" sz="950">
                 <a:solidFill>
                   <a:srgbClr val="5A6378"/>
                 </a:solidFill>
@@ -6631,9 +6848,9 @@
                 <a:ea typeface="Calibri" pitchFamily="34" charset="-122"/>
                 <a:cs typeface="Calibri" pitchFamily="34" charset="-120"/>
               </a:rPr>
-              <a:t>Transaction, certificate, signature, audit entry</a:t>
-            </a:r>
-            <a:endParaRPr lang="en-US" sz="1300" dirty="0"/>
+              <a:t>A2-style draft, RBI checks, papers list</a:t>
+            </a:r>
+            <a:endParaRPr lang="en-US" sz="950" dirty="0"/>
           </a:p>
         </p:txBody>
       </p:sp>
@@ -6663,6 +6880,13 @@
             <a:prstDash val="solid"/>
           </a:ln>
         </p:spPr>
+        <p:txBody>
+          <a:bodyPr/>
+          <a:lstStyle/>
+          <a:p>
+            <a:endParaRPr lang="en-IN"/>
+          </a:p>
+        </p:txBody>
       </p:sp>
       <p:sp>
         <p:nvSpPr>
@@ -6768,6 +6992,13 @@
             <a:prstDash val="solid"/>
           </a:ln>
         </p:spPr>
+        <p:txBody>
+          <a:bodyPr/>
+          <a:lstStyle/>
+          <a:p>
+            <a:endParaRPr lang="en-IN"/>
+          </a:p>
+        </p:txBody>
       </p:sp>
       <p:sp>
         <p:nvSpPr>
@@ -6873,6 +7104,13 @@
             <a:prstDash val="solid"/>
           </a:ln>
         </p:spPr>
+        <p:txBody>
+          <a:bodyPr/>
+          <a:lstStyle/>
+          <a:p>
+            <a:endParaRPr lang="en-IN"/>
+          </a:p>
+        </p:txBody>
       </p:sp>
       <p:sp>
         <p:nvSpPr>
@@ -6973,6 +7211,13 @@
           </a:solidFill>
           <a:ln/>
         </p:spPr>
+        <p:txBody>
+          <a:bodyPr/>
+          <a:lstStyle/>
+          <a:p>
+            <a:endParaRPr lang="en-IN"/>
+          </a:p>
+        </p:txBody>
       </p:sp>
       <p:sp>
         <p:nvSpPr>
@@ -7058,6 +7303,412 @@
               <a:t>3</a:t>
             </a:fld>
             <a:endParaRPr lang="en-US"/>
+          </a:p>
+        </p:txBody>
+      </p:sp>
+      <p:sp>
+        <p:nvSpPr>
+          <p:cNvPr id="45" name="Shape 26">
+            <a:extLst>
+              <a:ext uri="{FF2B5EF4-FFF2-40B4-BE49-F238E27FC236}">
+                <a16:creationId xmlns:a16="http://schemas.microsoft.com/office/drawing/2014/main" id="{C61D8855-DFBB-192E-2257-74F15552101F}"/>
+              </a:ext>
+            </a:extLst>
+          </p:cNvPr>
+          <p:cNvSpPr/>
+          <p:nvPr/>
+        </p:nvSpPr>
+        <p:spPr>
+          <a:xfrm>
+            <a:off x="8960757" y="1371600"/>
+            <a:ext cx="1244600" cy="2331720"/>
+          </a:xfrm>
+          <a:prstGeom prst="roundRect">
+            <a:avLst>
+              <a:gd name="adj" fmla="val 6383"/>
+            </a:avLst>
+          </a:prstGeom>
+          <a:solidFill>
+            <a:srgbClr val="F3F5F9"/>
+          </a:solidFill>
+          <a:ln/>
+        </p:spPr>
+        <p:txBody>
+          <a:bodyPr/>
+          <a:lstStyle/>
+          <a:p>
+            <a:endParaRPr lang="en-IN"/>
+          </a:p>
+        </p:txBody>
+      </p:sp>
+      <p:sp>
+        <p:nvSpPr>
+          <p:cNvPr id="46" name="Shape 27">
+            <a:extLst>
+              <a:ext uri="{FF2B5EF4-FFF2-40B4-BE49-F238E27FC236}">
+                <a16:creationId xmlns:a16="http://schemas.microsoft.com/office/drawing/2014/main" id="{9D80A84E-88F1-3614-FE6B-14667D2FC087}"/>
+              </a:ext>
+            </a:extLst>
+          </p:cNvPr>
+          <p:cNvSpPr/>
+          <p:nvPr/>
+        </p:nvSpPr>
+        <p:spPr>
+          <a:xfrm>
+            <a:off x="9113157" y="1572768"/>
+            <a:ext cx="502920" cy="502920"/>
+          </a:xfrm>
+          <a:prstGeom prst="ellipse">
+            <a:avLst/>
+          </a:prstGeom>
+          <a:solidFill>
+            <a:srgbClr val="1F5FA8"/>
+          </a:solidFill>
+          <a:ln/>
+        </p:spPr>
+        <p:txBody>
+          <a:bodyPr/>
+          <a:lstStyle/>
+          <a:p>
+            <a:endParaRPr lang="en-IN"/>
+          </a:p>
+        </p:txBody>
+      </p:sp>
+      <p:sp>
+        <p:nvSpPr>
+          <p:cNvPr id="47" name="Text 28">
+            <a:extLst>
+              <a:ext uri="{FF2B5EF4-FFF2-40B4-BE49-F238E27FC236}">
+                <a16:creationId xmlns:a16="http://schemas.microsoft.com/office/drawing/2014/main" id="{F2D691FD-BB4A-F13B-A1B7-5825FAC50A8E}"/>
+              </a:ext>
+            </a:extLst>
+          </p:cNvPr>
+          <p:cNvSpPr txBox="1"/>
+          <p:nvPr/>
+        </p:nvSpPr>
+        <p:spPr>
+          <a:xfrm>
+            <a:off x="9113157" y="1572768"/>
+            <a:ext cx="502920" cy="502920"/>
+          </a:xfrm>
+          <a:prstGeom prst="rect">
+            <a:avLst/>
+          </a:prstGeom>
+          <a:noFill/>
+          <a:ln/>
+        </p:spPr>
+        <p:txBody>
+          <a:bodyPr wrap="square" lIns="0" tIns="0" rIns="0" bIns="0" rtlCol="0" anchor="ctr"/>
+          <a:lstStyle/>
+          <a:p>
+            <a:pPr marL="0" indent="0" algn="ctr">
+              <a:buNone/>
+            </a:pPr>
+            <a:r>
+              <a:rPr lang="en-US" sz="1800" b="1">
+                <a:solidFill>
+                  <a:srgbClr val="FFFFFF"/>
+                </a:solidFill>
+                <a:latin typeface="Calibri" pitchFamily="34" charset="0"/>
+                <a:ea typeface="Calibri" pitchFamily="34" charset="-122"/>
+                <a:cs typeface="Calibri" pitchFamily="34" charset="-120"/>
+              </a:rPr>
+              <a:t>7</a:t>
+            </a:r>
+            <a:endParaRPr lang="en-US" sz="1800" dirty="0"/>
+          </a:p>
+        </p:txBody>
+      </p:sp>
+      <p:sp>
+        <p:nvSpPr>
+          <p:cNvPr id="48" name="Text 29">
+            <a:extLst>
+              <a:ext uri="{FF2B5EF4-FFF2-40B4-BE49-F238E27FC236}">
+                <a16:creationId xmlns:a16="http://schemas.microsoft.com/office/drawing/2014/main" id="{95538B0B-E46D-599D-1B7D-C7718F45427A}"/>
+              </a:ext>
+            </a:extLst>
+          </p:cNvPr>
+          <p:cNvSpPr txBox="1"/>
+          <p:nvPr/>
+        </p:nvSpPr>
+        <p:spPr>
+          <a:xfrm>
+            <a:off x="9062357" y="2194560"/>
+            <a:ext cx="1041400" cy="381000"/>
+          </a:xfrm>
+          <a:prstGeom prst="rect">
+            <a:avLst/>
+          </a:prstGeom>
+          <a:noFill/>
+          <a:ln/>
+        </p:spPr>
+        <p:txBody>
+          <a:bodyPr wrap="square" lIns="0" tIns="0" rIns="0" bIns="0" rtlCol="0" anchor="t"/>
+          <a:lstStyle/>
+          <a:p>
+            <a:pPr marL="0" indent="0">
+              <a:buNone/>
+            </a:pPr>
+            <a:r>
+              <a:rPr lang="en-US" sz="1100" b="1">
+                <a:solidFill>
+                  <a:srgbClr val="14213D"/>
+                </a:solidFill>
+                <a:latin typeface="Calibri" pitchFamily="34" charset="0"/>
+                <a:ea typeface="Calibri" pitchFamily="34" charset="-122"/>
+                <a:cs typeface="Calibri" pitchFamily="34" charset="-120"/>
+              </a:rPr>
+              <a:t>Review &amp; sign</a:t>
+            </a:r>
+            <a:endParaRPr lang="en-US" sz="1100" dirty="0"/>
+          </a:p>
+        </p:txBody>
+      </p:sp>
+      <p:sp>
+        <p:nvSpPr>
+          <p:cNvPr id="49" name="Text 30">
+            <a:extLst>
+              <a:ext uri="{FF2B5EF4-FFF2-40B4-BE49-F238E27FC236}">
+                <a16:creationId xmlns:a16="http://schemas.microsoft.com/office/drawing/2014/main" id="{F23BA966-D9D5-55AF-5F1A-17171859C326}"/>
+              </a:ext>
+            </a:extLst>
+          </p:cNvPr>
+          <p:cNvSpPr txBox="1"/>
+          <p:nvPr/>
+        </p:nvSpPr>
+        <p:spPr>
+          <a:xfrm>
+            <a:off x="9062357" y="2628900"/>
+            <a:ext cx="1041400" cy="1005840"/>
+          </a:xfrm>
+          <a:prstGeom prst="rect">
+            <a:avLst/>
+          </a:prstGeom>
+          <a:noFill/>
+          <a:ln/>
+        </p:spPr>
+        <p:txBody>
+          <a:bodyPr wrap="square" lIns="0" tIns="0" rIns="0" bIns="0" rtlCol="0" anchor="t"/>
+          <a:lstStyle/>
+          <a:p>
+            <a:pPr marL="0" indent="0">
+              <a:buNone/>
+            </a:pPr>
+            <a:r>
+              <a:rPr lang="en-US" sz="950">
+                <a:solidFill>
+                  <a:srgbClr val="5A6378"/>
+                </a:solidFill>
+                <a:latin typeface="Calibri" pitchFamily="34" charset="0"/>
+                <a:ea typeface="Calibri" pitchFamily="34" charset="-122"/>
+                <a:cs typeface="Calibri" pitchFamily="34" charset="-120"/>
+              </a:rPr>
+              <a:t>PIN pad; the parent's device signs the plan</a:t>
+            </a:r>
+            <a:endParaRPr lang="en-US" sz="950" dirty="0"/>
+          </a:p>
+        </p:txBody>
+      </p:sp>
+      <p:sp>
+        <p:nvSpPr>
+          <p:cNvPr id="50" name="Shape 26">
+            <a:extLst>
+              <a:ext uri="{FF2B5EF4-FFF2-40B4-BE49-F238E27FC236}">
+                <a16:creationId xmlns:a16="http://schemas.microsoft.com/office/drawing/2014/main" id="{84EE8BA8-F354-6A24-E6DB-83D27FD0EFA5}"/>
+              </a:ext>
+            </a:extLst>
+          </p:cNvPr>
+          <p:cNvSpPr/>
+          <p:nvPr/>
+        </p:nvSpPr>
+        <p:spPr>
+          <a:xfrm>
+            <a:off x="10363200" y="1371600"/>
+            <a:ext cx="1244600" cy="2331720"/>
+          </a:xfrm>
+          <a:prstGeom prst="roundRect">
+            <a:avLst>
+              <a:gd name="adj" fmla="val 6383"/>
+            </a:avLst>
+          </a:prstGeom>
+          <a:solidFill>
+            <a:srgbClr val="F3F5F9"/>
+          </a:solidFill>
+          <a:ln/>
+        </p:spPr>
+        <p:txBody>
+          <a:bodyPr/>
+          <a:lstStyle/>
+          <a:p>
+            <a:endParaRPr lang="en-IN"/>
+          </a:p>
+        </p:txBody>
+      </p:sp>
+      <p:sp>
+        <p:nvSpPr>
+          <p:cNvPr id="51" name="Shape 27">
+            <a:extLst>
+              <a:ext uri="{FF2B5EF4-FFF2-40B4-BE49-F238E27FC236}">
+                <a16:creationId xmlns:a16="http://schemas.microsoft.com/office/drawing/2014/main" id="{A78970FF-E4ED-0EDA-2EA2-87A8ED270D0A}"/>
+              </a:ext>
+            </a:extLst>
+          </p:cNvPr>
+          <p:cNvSpPr/>
+          <p:nvPr/>
+        </p:nvSpPr>
+        <p:spPr>
+          <a:xfrm>
+            <a:off x="10515600" y="1572768"/>
+            <a:ext cx="502920" cy="502920"/>
+          </a:xfrm>
+          <a:prstGeom prst="ellipse">
+            <a:avLst/>
+          </a:prstGeom>
+          <a:solidFill>
+            <a:srgbClr val="1F5FA8"/>
+          </a:solidFill>
+          <a:ln/>
+        </p:spPr>
+        <p:txBody>
+          <a:bodyPr/>
+          <a:lstStyle/>
+          <a:p>
+            <a:endParaRPr lang="en-IN"/>
+          </a:p>
+        </p:txBody>
+      </p:sp>
+      <p:sp>
+        <p:nvSpPr>
+          <p:cNvPr id="52" name="Text 28">
+            <a:extLst>
+              <a:ext uri="{FF2B5EF4-FFF2-40B4-BE49-F238E27FC236}">
+                <a16:creationId xmlns:a16="http://schemas.microsoft.com/office/drawing/2014/main" id="{3C0CF6D4-134F-76E0-C45E-95E87107CCD0}"/>
+              </a:ext>
+            </a:extLst>
+          </p:cNvPr>
+          <p:cNvSpPr txBox="1"/>
+          <p:nvPr/>
+        </p:nvSpPr>
+        <p:spPr>
+          <a:xfrm>
+            <a:off x="10515600" y="1572768"/>
+            <a:ext cx="502920" cy="502920"/>
+          </a:xfrm>
+          <a:prstGeom prst="rect">
+            <a:avLst/>
+          </a:prstGeom>
+          <a:noFill/>
+          <a:ln/>
+        </p:spPr>
+        <p:txBody>
+          <a:bodyPr wrap="square" lIns="0" tIns="0" rIns="0" bIns="0" rtlCol="0" anchor="ctr"/>
+          <a:lstStyle/>
+          <a:p>
+            <a:pPr marL="0" indent="0" algn="ctr">
+              <a:buNone/>
+            </a:pPr>
+            <a:r>
+              <a:rPr lang="en-US" sz="1800" b="1">
+                <a:solidFill>
+                  <a:srgbClr val="FFFFFF"/>
+                </a:solidFill>
+                <a:latin typeface="Calibri" pitchFamily="34" charset="0"/>
+                <a:ea typeface="Calibri" pitchFamily="34" charset="-122"/>
+                <a:cs typeface="Calibri" pitchFamily="34" charset="-120"/>
+              </a:rPr>
+              <a:t>8</a:t>
+            </a:r>
+            <a:endParaRPr lang="en-US" sz="1800" dirty="0"/>
+          </a:p>
+        </p:txBody>
+      </p:sp>
+      <p:sp>
+        <p:nvSpPr>
+          <p:cNvPr id="53" name="Text 29">
+            <a:extLst>
+              <a:ext uri="{FF2B5EF4-FFF2-40B4-BE49-F238E27FC236}">
+                <a16:creationId xmlns:a16="http://schemas.microsoft.com/office/drawing/2014/main" id="{FAA8B911-3018-5E66-2C1F-91423A4AD1C4}"/>
+              </a:ext>
+            </a:extLst>
+          </p:cNvPr>
+          <p:cNvSpPr txBox="1"/>
+          <p:nvPr/>
+        </p:nvSpPr>
+        <p:spPr>
+          <a:xfrm>
+            <a:off x="10464800" y="2194560"/>
+            <a:ext cx="1041400" cy="381000"/>
+          </a:xfrm>
+          <a:prstGeom prst="rect">
+            <a:avLst/>
+          </a:prstGeom>
+          <a:noFill/>
+          <a:ln/>
+        </p:spPr>
+        <p:txBody>
+          <a:bodyPr wrap="square" lIns="0" tIns="0" rIns="0" bIns="0" rtlCol="0" anchor="t"/>
+          <a:lstStyle/>
+          <a:p>
+            <a:pPr marL="0" indent="0">
+              <a:buNone/>
+            </a:pPr>
+            <a:r>
+              <a:rPr lang="en-US" sz="1100" b="1">
+                <a:solidFill>
+                  <a:srgbClr val="14213D"/>
+                </a:solidFill>
+                <a:latin typeface="Calibri" pitchFamily="34" charset="0"/>
+                <a:ea typeface="Calibri" pitchFamily="34" charset="-122"/>
+                <a:cs typeface="Calibri" pitchFamily="34" charset="-120"/>
+              </a:rPr>
+              <a:t>Receipt</a:t>
+            </a:r>
+            <a:endParaRPr lang="en-US" sz="1100" dirty="0"/>
+          </a:p>
+        </p:txBody>
+      </p:sp>
+      <p:sp>
+        <p:nvSpPr>
+          <p:cNvPr id="54" name="Text 30">
+            <a:extLst>
+              <a:ext uri="{FF2B5EF4-FFF2-40B4-BE49-F238E27FC236}">
+                <a16:creationId xmlns:a16="http://schemas.microsoft.com/office/drawing/2014/main" id="{3CD3F4CE-4E4A-E2B8-CA5C-871B0CBEF392}"/>
+              </a:ext>
+            </a:extLst>
+          </p:cNvPr>
+          <p:cNvSpPr txBox="1"/>
+          <p:nvPr/>
+        </p:nvSpPr>
+        <p:spPr>
+          <a:xfrm>
+            <a:off x="10464800" y="2628900"/>
+            <a:ext cx="1041400" cy="1005840"/>
+          </a:xfrm>
+          <a:prstGeom prst="rect">
+            <a:avLst/>
+          </a:prstGeom>
+          <a:noFill/>
+          <a:ln/>
+        </p:spPr>
+        <p:txBody>
+          <a:bodyPr wrap="square" lIns="0" tIns="0" rIns="0" bIns="0" rtlCol="0" anchor="t"/>
+          <a:lstStyle/>
+          <a:p>
+            <a:pPr marL="0" indent="0">
+              <a:buNone/>
+            </a:pPr>
+            <a:r>
+              <a:rPr lang="fr-FR" sz="950">
+                <a:solidFill>
+                  <a:srgbClr val="5A6378"/>
+                </a:solidFill>
+                <a:latin typeface="Calibri" pitchFamily="34" charset="0"/>
+                <a:ea typeface="Calibri" pitchFamily="34" charset="-122"/>
+                <a:cs typeface="Calibri" pitchFamily="34" charset="-120"/>
+              </a:rPr>
+              <a:t>Printable: transaction, signature, audit entry</a:t>
+            </a:r>
+            <a:endParaRPr lang="en-US" sz="950" dirty="0"/>
           </a:p>
         </p:txBody>
       </p:sp>
@@ -7293,41 +7944,6 @@
           </a:p>
         </p:txBody>
       </p:sp>
-      <p:pic>
-        <p:nvPicPr>
-          <p:cNvPr id="47" name="Picture 46">
-            <a:extLst>
-              <a:ext uri="{FF2B5EF4-FFF2-40B4-BE49-F238E27FC236}">
-                <a16:creationId xmlns:a16="http://schemas.microsoft.com/office/drawing/2014/main" id="{1B7A7462-0B3C-5311-1733-F21733A383E2}"/>
-              </a:ext>
-            </a:extLst>
-          </p:cNvPr>
-          <p:cNvPicPr>
-            <a:picLocks/>
-          </p:cNvPicPr>
-          <p:nvPr/>
-        </p:nvPicPr>
-        <p:blipFill>
-          <a:blip r:embed="rId3"/>
-          <a:stretch>
-            <a:fillRect/>
-          </a:stretch>
-        </p:blipFill>
-        <p:spPr>
-          <a:xfrm>
-            <a:off x="4445000" y="1320800"/>
-            <a:ext cx="3479800" cy="2159000"/>
-          </a:xfrm>
-          <a:prstGeom prst="rect">
-            <a:avLst/>
-          </a:prstGeom>
-          <a:ln w="9525">
-            <a:solidFill>
-              <a:srgbClr val="DBDBDB"/>
-            </a:solidFill>
-          </a:ln>
-        </p:spPr>
-      </p:pic>
       <p:sp>
         <p:nvSpPr>
           <p:cNvPr id="48" name="TextBox 47">
@@ -7374,41 +7990,6 @@
           </a:p>
         </p:txBody>
       </p:sp>
-      <p:pic>
-        <p:nvPicPr>
-          <p:cNvPr id="50" name="Picture 49">
-            <a:extLst>
-              <a:ext uri="{FF2B5EF4-FFF2-40B4-BE49-F238E27FC236}">
-                <a16:creationId xmlns:a16="http://schemas.microsoft.com/office/drawing/2014/main" id="{9B22E8E5-20A5-E081-A529-690C7D37D423}"/>
-              </a:ext>
-            </a:extLst>
-          </p:cNvPr>
-          <p:cNvPicPr>
-            <a:picLocks/>
-          </p:cNvPicPr>
-          <p:nvPr/>
-        </p:nvPicPr>
-        <p:blipFill>
-          <a:blip r:embed="rId4"/>
-          <a:stretch>
-            <a:fillRect/>
-          </a:stretch>
-        </p:blipFill>
-        <p:spPr>
-          <a:xfrm>
-            <a:off x="8128000" y="1320800"/>
-            <a:ext cx="3479800" cy="2159000"/>
-          </a:xfrm>
-          <a:prstGeom prst="rect">
-            <a:avLst/>
-          </a:prstGeom>
-          <a:ln w="9525">
-            <a:solidFill>
-              <a:srgbClr val="DBDBDB"/>
-            </a:solidFill>
-          </a:ln>
-        </p:spPr>
-      </p:pic>
       <p:sp>
         <p:nvSpPr>
           <p:cNvPr id="51" name="TextBox 50">
@@ -7455,41 +8036,6 @@
           </a:p>
         </p:txBody>
       </p:sp>
-      <p:pic>
-        <p:nvPicPr>
-          <p:cNvPr id="53" name="Picture 52">
-            <a:extLst>
-              <a:ext uri="{FF2B5EF4-FFF2-40B4-BE49-F238E27FC236}">
-                <a16:creationId xmlns:a16="http://schemas.microsoft.com/office/drawing/2014/main" id="{FC98E358-E0F6-F3B6-5EC1-8A0DB59EBA25}"/>
-              </a:ext>
-            </a:extLst>
-          </p:cNvPr>
-          <p:cNvPicPr>
-            <a:picLocks/>
-          </p:cNvPicPr>
-          <p:nvPr/>
-        </p:nvPicPr>
-        <p:blipFill>
-          <a:blip r:embed="rId5"/>
-          <a:stretch>
-            <a:fillRect/>
-          </a:stretch>
-        </p:blipFill>
-        <p:spPr>
-          <a:xfrm>
-            <a:off x="4445000" y="3810000"/>
-            <a:ext cx="3479800" cy="2159000"/>
-          </a:xfrm>
-          <a:prstGeom prst="rect">
-            <a:avLst/>
-          </a:prstGeom>
-          <a:ln w="9525">
-            <a:solidFill>
-              <a:srgbClr val="DBDBDB"/>
-            </a:solidFill>
-          </a:ln>
-        </p:spPr>
-      </p:pic>
       <p:sp>
         <p:nvSpPr>
           <p:cNvPr id="54" name="TextBox 53">
@@ -7536,41 +8082,6 @@
           </a:p>
         </p:txBody>
       </p:sp>
-      <p:pic>
-        <p:nvPicPr>
-          <p:cNvPr id="56" name="Picture 55">
-            <a:extLst>
-              <a:ext uri="{FF2B5EF4-FFF2-40B4-BE49-F238E27FC236}">
-                <a16:creationId xmlns:a16="http://schemas.microsoft.com/office/drawing/2014/main" id="{AABB2022-FCF0-3BE9-1D50-38A934466BC2}"/>
-              </a:ext>
-            </a:extLst>
-          </p:cNvPr>
-          <p:cNvPicPr>
-            <a:picLocks/>
-          </p:cNvPicPr>
-          <p:nvPr/>
-        </p:nvPicPr>
-        <p:blipFill>
-          <a:blip r:embed="rId6"/>
-          <a:stretch>
-            <a:fillRect/>
-          </a:stretch>
-        </p:blipFill>
-        <p:spPr>
-          <a:xfrm>
-            <a:off x="8128000" y="3810000"/>
-            <a:ext cx="3479800" cy="2159000"/>
-          </a:xfrm>
-          <a:prstGeom prst="rect">
-            <a:avLst/>
-          </a:prstGeom>
-          <a:ln w="9525">
-            <a:solidFill>
-              <a:srgbClr val="DBDBDB"/>
-            </a:solidFill>
-          </a:ln>
-        </p:spPr>
-      </p:pic>
       <p:sp>
         <p:nvSpPr>
           <p:cNvPr id="57" name="TextBox 56">
@@ -7617,6 +8128,146 @@
           </a:p>
         </p:txBody>
       </p:sp>
+      <p:pic>
+        <p:nvPicPr>
+          <p:cNvPr id="4" name="Picture 3">
+            <a:extLst>
+              <a:ext uri="{FF2B5EF4-FFF2-40B4-BE49-F238E27FC236}">
+                <a16:creationId xmlns:a16="http://schemas.microsoft.com/office/drawing/2014/main" id="{7FEB051A-F088-F027-4A84-2BC9D4DE8101}"/>
+              </a:ext>
+            </a:extLst>
+          </p:cNvPr>
+          <p:cNvPicPr>
+            <a:picLocks/>
+          </p:cNvPicPr>
+          <p:nvPr/>
+        </p:nvPicPr>
+        <p:blipFill>
+          <a:blip r:embed="rId3"/>
+          <a:stretch>
+            <a:fillRect/>
+          </a:stretch>
+        </p:blipFill>
+        <p:spPr>
+          <a:xfrm>
+            <a:off x="4445000" y="1320800"/>
+            <a:ext cx="3479800" cy="2159000"/>
+          </a:xfrm>
+          <a:prstGeom prst="rect">
+            <a:avLst/>
+          </a:prstGeom>
+          <a:ln w="9525">
+            <a:solidFill>
+              <a:srgbClr val="DBDBDB"/>
+            </a:solidFill>
+          </a:ln>
+        </p:spPr>
+      </p:pic>
+      <p:pic>
+        <p:nvPicPr>
+          <p:cNvPr id="6" name="Picture 5">
+            <a:extLst>
+              <a:ext uri="{FF2B5EF4-FFF2-40B4-BE49-F238E27FC236}">
+                <a16:creationId xmlns:a16="http://schemas.microsoft.com/office/drawing/2014/main" id="{D2483DBF-C457-7572-CA40-E635F6B7BA52}"/>
+              </a:ext>
+            </a:extLst>
+          </p:cNvPr>
+          <p:cNvPicPr>
+            <a:picLocks/>
+          </p:cNvPicPr>
+          <p:nvPr/>
+        </p:nvPicPr>
+        <p:blipFill>
+          <a:blip r:embed="rId4"/>
+          <a:stretch>
+            <a:fillRect/>
+          </a:stretch>
+        </p:blipFill>
+        <p:spPr>
+          <a:xfrm>
+            <a:off x="8128000" y="1320800"/>
+            <a:ext cx="3479800" cy="2159000"/>
+          </a:xfrm>
+          <a:prstGeom prst="rect">
+            <a:avLst/>
+          </a:prstGeom>
+          <a:ln w="9525">
+            <a:solidFill>
+              <a:srgbClr val="DBDBDB"/>
+            </a:solidFill>
+          </a:ln>
+        </p:spPr>
+      </p:pic>
+      <p:pic>
+        <p:nvPicPr>
+          <p:cNvPr id="8" name="Picture 7">
+            <a:extLst>
+              <a:ext uri="{FF2B5EF4-FFF2-40B4-BE49-F238E27FC236}">
+                <a16:creationId xmlns:a16="http://schemas.microsoft.com/office/drawing/2014/main" id="{7E954085-5698-092D-87EF-BCBA824FA498}"/>
+              </a:ext>
+            </a:extLst>
+          </p:cNvPr>
+          <p:cNvPicPr>
+            <a:picLocks/>
+          </p:cNvPicPr>
+          <p:nvPr/>
+        </p:nvPicPr>
+        <p:blipFill>
+          <a:blip r:embed="rId5"/>
+          <a:stretch>
+            <a:fillRect/>
+          </a:stretch>
+        </p:blipFill>
+        <p:spPr>
+          <a:xfrm>
+            <a:off x="4445000" y="3810000"/>
+            <a:ext cx="3479800" cy="2159000"/>
+          </a:xfrm>
+          <a:prstGeom prst="rect">
+            <a:avLst/>
+          </a:prstGeom>
+          <a:ln w="9525">
+            <a:solidFill>
+              <a:srgbClr val="DBDBDB"/>
+            </a:solidFill>
+          </a:ln>
+        </p:spPr>
+      </p:pic>
+      <p:pic>
+        <p:nvPicPr>
+          <p:cNvPr id="10" name="Picture 9">
+            <a:extLst>
+              <a:ext uri="{FF2B5EF4-FFF2-40B4-BE49-F238E27FC236}">
+                <a16:creationId xmlns:a16="http://schemas.microsoft.com/office/drawing/2014/main" id="{4F30C1D6-D7DB-68C8-8853-BEE2DDAD7634}"/>
+              </a:ext>
+            </a:extLst>
+          </p:cNvPr>
+          <p:cNvPicPr>
+            <a:picLocks/>
+          </p:cNvPicPr>
+          <p:nvPr/>
+        </p:nvPicPr>
+        <p:blipFill>
+          <a:blip r:embed="rId6"/>
+          <a:stretch>
+            <a:fillRect/>
+          </a:stretch>
+        </p:blipFill>
+        <p:spPr>
+          <a:xfrm>
+            <a:off x="8128000" y="3810000"/>
+            <a:ext cx="3479800" cy="2159000"/>
+          </a:xfrm>
+          <a:prstGeom prst="rect">
+            <a:avLst/>
+          </a:prstGeom>
+          <a:ln w="9525">
+            <a:solidFill>
+              <a:srgbClr val="DBDBDB"/>
+            </a:solidFill>
+          </a:ln>
+        </p:spPr>
+      </p:pic>
     </p:spTree>
     <p:extLst>
       <p:ext uri="{BB962C8B-B14F-4D97-AF65-F5344CB8AC3E}">
@@ -7735,6 +8386,13 @@
           </a:solidFill>
           <a:ln/>
         </p:spPr>
+        <p:txBody>
+          <a:bodyPr/>
+          <a:lstStyle/>
+          <a:p>
+            <a:endParaRPr lang="en-IN"/>
+          </a:p>
+        </p:txBody>
       </p:sp>
       <p:sp>
         <p:nvSpPr>
@@ -7835,6 +8493,13 @@
           </a:solidFill>
           <a:ln/>
         </p:spPr>
+        <p:txBody>
+          <a:bodyPr/>
+          <a:lstStyle/>
+          <a:p>
+            <a:endParaRPr lang="en-IN"/>
+          </a:p>
+        </p:txBody>
       </p:sp>
       <p:sp>
         <p:nvSpPr>
@@ -7935,6 +8600,13 @@
           </a:solidFill>
           <a:ln/>
         </p:spPr>
+        <p:txBody>
+          <a:bodyPr/>
+          <a:lstStyle/>
+          <a:p>
+            <a:endParaRPr lang="en-IN"/>
+          </a:p>
+        </p:txBody>
       </p:sp>
       <p:sp>
         <p:nvSpPr>
@@ -9436,6 +10108,13 @@
           </a:solidFill>
           <a:ln/>
         </p:spPr>
+        <p:txBody>
+          <a:bodyPr/>
+          <a:lstStyle/>
+          <a:p>
+            <a:endParaRPr lang="en-IN"/>
+          </a:p>
+        </p:txBody>
       </p:sp>
       <p:sp>
         <p:nvSpPr>
@@ -9518,6 +10197,13 @@
             <a:prstDash val="solid"/>
           </a:ln>
         </p:spPr>
+        <p:txBody>
+          <a:bodyPr/>
+          <a:lstStyle/>
+          <a:p>
+            <a:endParaRPr lang="en-IN"/>
+          </a:p>
+        </p:txBody>
       </p:sp>
       <p:sp>
         <p:nvSpPr>
@@ -9853,6 +10539,13 @@
             <a:prstDash val="solid"/>
           </a:ln>
         </p:spPr>
+        <p:txBody>
+          <a:bodyPr/>
+          <a:lstStyle/>
+          <a:p>
+            <a:endParaRPr lang="en-IN"/>
+          </a:p>
+        </p:txBody>
       </p:sp>
       <p:sp>
         <p:nvSpPr>
@@ -10124,6 +10817,13 @@
           </a:solidFill>
           <a:ln/>
         </p:spPr>
+        <p:txBody>
+          <a:bodyPr/>
+          <a:lstStyle/>
+          <a:p>
+            <a:endParaRPr lang="en-IN"/>
+          </a:p>
+        </p:txBody>
       </p:sp>
       <p:sp>
         <p:nvSpPr>
@@ -10420,6 +11120,13 @@
             <a:prstDash val="solid"/>
           </a:ln>
         </p:spPr>
+        <p:txBody>
+          <a:bodyPr/>
+          <a:lstStyle/>
+          <a:p>
+            <a:endParaRPr lang="en-IN"/>
+          </a:p>
+        </p:txBody>
       </p:sp>
       <p:sp>
         <p:nvSpPr>
@@ -10764,6 +11471,13 @@
           </a:solidFill>
           <a:ln/>
         </p:spPr>
+        <p:txBody>
+          <a:bodyPr/>
+          <a:lstStyle/>
+          <a:p>
+            <a:endParaRPr lang="en-IN"/>
+          </a:p>
+        </p:txBody>
       </p:sp>
       <p:sp>
         <p:nvSpPr>
@@ -10862,6 +11576,13 @@
           </a:solidFill>
           <a:ln/>
         </p:spPr>
+        <p:txBody>
+          <a:bodyPr/>
+          <a:lstStyle/>
+          <a:p>
+            <a:endParaRPr lang="en-IN"/>
+          </a:p>
+        </p:txBody>
       </p:sp>
       <p:sp>
         <p:nvSpPr>
@@ -10884,6 +11605,13 @@
           </a:solidFill>
           <a:ln/>
         </p:spPr>
+        <p:txBody>
+          <a:bodyPr/>
+          <a:lstStyle/>
+          <a:p>
+            <a:endParaRPr lang="en-IN"/>
+          </a:p>
+        </p:txBody>
       </p:sp>
       <p:sp>
         <p:nvSpPr>
@@ -10982,6 +11710,13 @@
           </a:solidFill>
           <a:ln/>
         </p:spPr>
+        <p:txBody>
+          <a:bodyPr/>
+          <a:lstStyle/>
+          <a:p>
+            <a:endParaRPr lang="en-IN"/>
+          </a:p>
+        </p:txBody>
       </p:sp>
       <p:sp>
         <p:nvSpPr>
@@ -11004,6 +11739,13 @@
           </a:solidFill>
           <a:ln/>
         </p:spPr>
+        <p:txBody>
+          <a:bodyPr/>
+          <a:lstStyle/>
+          <a:p>
+            <a:endParaRPr lang="en-IN"/>
+          </a:p>
+        </p:txBody>
       </p:sp>
       <p:sp>
         <p:nvSpPr>
@@ -11102,6 +11844,13 @@
           </a:solidFill>
           <a:ln/>
         </p:spPr>
+        <p:txBody>
+          <a:bodyPr/>
+          <a:lstStyle/>
+          <a:p>
+            <a:endParaRPr lang="en-IN"/>
+          </a:p>
+        </p:txBody>
       </p:sp>
       <p:sp>
         <p:nvSpPr>
@@ -11124,6 +11873,13 @@
           </a:solidFill>
           <a:ln/>
         </p:spPr>
+        <p:txBody>
+          <a:bodyPr/>
+          <a:lstStyle/>
+          <a:p>
+            <a:endParaRPr lang="en-IN"/>
+          </a:p>
+        </p:txBody>
       </p:sp>
       <p:sp>
         <p:nvSpPr>
@@ -11222,6 +11978,13 @@
           </a:solidFill>
           <a:ln/>
         </p:spPr>
+        <p:txBody>
+          <a:bodyPr/>
+          <a:lstStyle/>
+          <a:p>
+            <a:endParaRPr lang="en-IN"/>
+          </a:p>
+        </p:txBody>
       </p:sp>
       <p:sp>
         <p:nvSpPr>
@@ -11244,6 +12007,13 @@
           </a:solidFill>
           <a:ln/>
         </p:spPr>
+        <p:txBody>
+          <a:bodyPr/>
+          <a:lstStyle/>
+          <a:p>
+            <a:endParaRPr lang="en-IN"/>
+          </a:p>
+        </p:txBody>
       </p:sp>
       <p:sp>
         <p:nvSpPr>
@@ -11399,6 +12169,13 @@
             <a:prstDash val="solid"/>
           </a:ln>
         </p:spPr>
+        <p:txBody>
+          <a:bodyPr/>
+          <a:lstStyle/>
+          <a:p>
+            <a:endParaRPr lang="en-IN"/>
+          </a:p>
+        </p:txBody>
       </p:sp>
       <p:sp>
         <p:nvSpPr>
@@ -11497,6 +12274,13 @@
           </a:solidFill>
           <a:ln/>
         </p:spPr>
+        <p:txBody>
+          <a:bodyPr/>
+          <a:lstStyle/>
+          <a:p>
+            <a:endParaRPr lang="en-IN"/>
+          </a:p>
+        </p:txBody>
       </p:sp>
       <p:sp>
         <p:nvSpPr>
@@ -11524,6 +12308,13 @@
             <a:prstDash val="solid"/>
           </a:ln>
         </p:spPr>
+        <p:txBody>
+          <a:bodyPr/>
+          <a:lstStyle/>
+          <a:p>
+            <a:endParaRPr lang="en-IN"/>
+          </a:p>
+        </p:txBody>
       </p:sp>
       <p:sp>
         <p:nvSpPr>
@@ -11622,6 +12413,13 @@
           </a:solidFill>
           <a:ln/>
         </p:spPr>
+        <p:txBody>
+          <a:bodyPr/>
+          <a:lstStyle/>
+          <a:p>
+            <a:endParaRPr lang="en-IN"/>
+          </a:p>
+        </p:txBody>
       </p:sp>
       <p:sp>
         <p:nvSpPr>
@@ -11649,6 +12447,13 @@
             <a:prstDash val="solid"/>
           </a:ln>
         </p:spPr>
+        <p:txBody>
+          <a:bodyPr/>
+          <a:lstStyle/>
+          <a:p>
+            <a:endParaRPr lang="en-IN"/>
+          </a:p>
+        </p:txBody>
       </p:sp>
       <p:sp>
         <p:nvSpPr>
@@ -11747,6 +12552,13 @@
           </a:solidFill>
           <a:ln/>
         </p:spPr>
+        <p:txBody>
+          <a:bodyPr/>
+          <a:lstStyle/>
+          <a:p>
+            <a:endParaRPr lang="en-IN"/>
+          </a:p>
+        </p:txBody>
       </p:sp>
       <p:sp>
         <p:nvSpPr>
@@ -11774,6 +12586,13 @@
             <a:prstDash val="solid"/>
           </a:ln>
         </p:spPr>
+        <p:txBody>
+          <a:bodyPr/>
+          <a:lstStyle/>
+          <a:p>
+            <a:endParaRPr lang="en-IN"/>
+          </a:p>
+        </p:txBody>
       </p:sp>
       <p:sp>
         <p:nvSpPr>
@@ -11872,6 +12691,13 @@
           </a:solidFill>
           <a:ln/>
         </p:spPr>
+        <p:txBody>
+          <a:bodyPr/>
+          <a:lstStyle/>
+          <a:p>
+            <a:endParaRPr lang="en-IN"/>
+          </a:p>
+        </p:txBody>
       </p:sp>
       <p:sp>
         <p:nvSpPr>
@@ -11899,6 +12725,13 @@
             <a:prstDash val="solid"/>
           </a:ln>
         </p:spPr>
+        <p:txBody>
+          <a:bodyPr/>
+          <a:lstStyle/>
+          <a:p>
+            <a:endParaRPr lang="en-IN"/>
+          </a:p>
+        </p:txBody>
       </p:sp>
       <p:sp>
         <p:nvSpPr>
@@ -11999,6 +12832,13 @@
           </a:solidFill>
           <a:ln/>
         </p:spPr>
+        <p:txBody>
+          <a:bodyPr/>
+          <a:lstStyle/>
+          <a:p>
+            <a:endParaRPr lang="en-IN"/>
+          </a:p>
+        </p:txBody>
       </p:sp>
       <p:sp>
         <p:nvSpPr>
@@ -13485,6 +14325,13 @@
           </a:solidFill>
           <a:ln/>
         </p:spPr>
+        <p:txBody>
+          <a:bodyPr/>
+          <a:lstStyle/>
+          <a:p>
+            <a:endParaRPr lang="en-IN"/>
+          </a:p>
+        </p:txBody>
       </p:sp>
       <p:sp>
         <p:nvSpPr>
@@ -13585,6 +14432,13 @@
           </a:solidFill>
           <a:ln/>
         </p:spPr>
+        <p:txBody>
+          <a:bodyPr/>
+          <a:lstStyle/>
+          <a:p>
+            <a:endParaRPr lang="en-IN"/>
+          </a:p>
+        </p:txBody>
       </p:sp>
       <p:sp>
         <p:nvSpPr>
@@ -13685,6 +14539,13 @@
           </a:solidFill>
           <a:ln/>
         </p:spPr>
+        <p:txBody>
+          <a:bodyPr/>
+          <a:lstStyle/>
+          <a:p>
+            <a:endParaRPr lang="en-IN"/>
+          </a:p>
+        </p:txBody>
       </p:sp>
       <p:sp>
         <p:nvSpPr>
@@ -13785,6 +14646,13 @@
           </a:solidFill>
           <a:ln/>
         </p:spPr>
+        <p:txBody>
+          <a:bodyPr/>
+          <a:lstStyle/>
+          <a:p>
+            <a:endParaRPr lang="en-IN"/>
+          </a:p>
+        </p:txBody>
       </p:sp>
       <p:sp>
         <p:nvSpPr>
@@ -13885,6 +14753,13 @@
           </a:solidFill>
           <a:ln/>
         </p:spPr>
+        <p:txBody>
+          <a:bodyPr/>
+          <a:lstStyle/>
+          <a:p>
+            <a:endParaRPr lang="en-IN"/>
+          </a:p>
+        </p:txBody>
       </p:sp>
       <p:sp>
         <p:nvSpPr>
@@ -13985,6 +14860,13 @@
           </a:solidFill>
           <a:ln/>
         </p:spPr>
+        <p:txBody>
+          <a:bodyPr/>
+          <a:lstStyle/>
+          <a:p>
+            <a:endParaRPr lang="en-IN"/>
+          </a:p>
+        </p:txBody>
       </p:sp>
       <p:sp>
         <p:nvSpPr>

</xml_diff>

<commit_message>
Docs: bring every document up to the 20 Oct features
- Architecture diagram (SVG, PNG and deck slide 5): 8 guided steps,
  assistant, Student money, cookie sessions, sanctions screening,
  financial-year timing and budget, RBI checks and source of funds,
  send-by/split/loan advice, hosted Claude opt-in.
- README intro and tour, TECHNICAL (what it does, module table, diagram
  legend), PROJECT_SUMMARY, team plan status (20 Oct), folder READMEs,
  docs index, CLAUDE.md layout, and the open-rules list in TODO.

Co-Authored-By: Claude Opus 5.5 <noreply@anthropic.com>
</commit_message>
<xml_diff>
--- a/docs/presentation/TuitionPilot_deck.pptx
+++ b/docs/presentation/TuitionPilot_deck.pptx
@@ -1878,7 +1878,7 @@
           </a:prstGeom>
           <a:extLst>
             <a:ext uri="{C572A759-6A51-4108-AA02-DFA0A04FC94B}">
-              <ma14:wrappingTextBoxFlag xmlns="" xmlns:ma14="http://schemas.microsoft.com/office/mac/drawingml/2011/main" val="0"/>
+              <ma14:wrappingTextBoxFlag xmlns:ma14="http://schemas.microsoft.com/office/mac/drawingml/2011/main" xmlns="" val="0"/>
             </a:ext>
           </a:extLst>
         </p:spPr>
@@ -1989,7 +1989,7 @@
           </a:prstGeom>
           <a:extLst>
             <a:ext uri="{C572A759-6A51-4108-AA02-DFA0A04FC94B}">
-              <ma14:wrappingTextBoxFlag xmlns="" xmlns:ma14="http://schemas.microsoft.com/office/mac/drawingml/2011/main" val="0"/>
+              <ma14:wrappingTextBoxFlag xmlns:ma14="http://schemas.microsoft.com/office/mac/drawingml/2011/main" xmlns="" val="0"/>
             </a:ext>
           </a:extLst>
         </p:spPr>
@@ -4722,7 +4722,7 @@
           </a:prstGeom>
           <a:extLst>
             <a:ext uri="{C572A759-6A51-4108-AA02-DFA0A04FC94B}">
-              <ma14:wrappingTextBoxFlag xmlns="" xmlns:ma14="http://schemas.microsoft.com/office/mac/drawingml/2011/main" val="0"/>
+              <ma14:wrappingTextBoxFlag xmlns:ma14="http://schemas.microsoft.com/office/mac/drawingml/2011/main" xmlns="" val="0"/>
             </a:ext>
           </a:extLst>
         </p:spPr>
@@ -5715,7 +5715,7 @@
           </a:prstGeom>
           <a:extLst>
             <a:ext uri="{C572A759-6A51-4108-AA02-DFA0A04FC94B}">
-              <ma14:wrappingTextBoxFlag xmlns="" xmlns:ma14="http://schemas.microsoft.com/office/mac/drawingml/2011/main" val="0"/>
+              <ma14:wrappingTextBoxFlag xmlns:ma14="http://schemas.microsoft.com/office/mac/drawingml/2011/main" xmlns="" val="0"/>
             </a:ext>
           </a:extLst>
         </p:spPr>
@@ -7278,7 +7278,7 @@
           </a:prstGeom>
           <a:extLst>
             <a:ext uri="{C572A759-6A51-4108-AA02-DFA0A04FC94B}">
-              <ma14:wrappingTextBoxFlag xmlns="" xmlns:ma14="http://schemas.microsoft.com/office/mac/drawingml/2011/main" val="0"/>
+              <ma14:wrappingTextBoxFlag xmlns:ma14="http://schemas.microsoft.com/office/mac/drawingml/2011/main" xmlns="" val="0"/>
             </a:ext>
           </a:extLst>
         </p:spPr>
@@ -7800,7 +7800,7 @@
           </a:prstGeom>
           <a:extLst>
             <a:ext uri="{C572A759-6A51-4108-AA02-DFA0A04FC94B}">
-              <ma14:wrappingTextBoxFlag xmlns:ma14="http://schemas.microsoft.com/office/mac/drawingml/2011/main" xmlns="" val="0"/>
+              <ma14:wrappingTextBoxFlag xmlns="" xmlns:ma14="http://schemas.microsoft.com/office/mac/drawingml/2011/main" val="0"/>
             </a:ext>
           </a:extLst>
         </p:spPr>
@@ -8298,6 +8298,36 @@
           <a:chExt cx="0" cy="0"/>
         </a:xfrm>
       </p:grpSpPr>
+      <p:pic>
+        <p:nvPicPr>
+          <p:cNvPr id="14" name="Image 0">
+            <a:extLst>
+              <a:ext uri="{FF2B5EF4-FFF2-40B4-BE49-F238E27FC236}">
+                <a16:creationId xmlns:a16="http://schemas.microsoft.com/office/drawing/2014/main" id="{C54C5D1C-1787-A526-4B84-34317D2F6D94}"/>
+              </a:ext>
+            </a:extLst>
+          </p:cNvPr>
+          <p:cNvPicPr>
+            <a:picLocks/>
+          </p:cNvPicPr>
+          <p:nvPr/>
+        </p:nvPicPr>
+        <p:blipFill>
+          <a:blip r:embed="rId3"/>
+          <a:stretch>
+            <a:fillRect/>
+          </a:stretch>
+        </p:blipFill>
+        <p:spPr>
+          <a:xfrm>
+            <a:off x="548640" y="1234440"/>
+            <a:ext cx="8046720" cy="5029200"/>
+          </a:xfrm>
+          <a:prstGeom prst="rect">
+            <a:avLst/>
+          </a:prstGeom>
+        </p:spPr>
+      </p:pic>
       <p:sp>
         <p:nvSpPr>
           <p:cNvPr id="2" name="Text 0"/>
@@ -8341,30 +8371,6 @@
           </a:p>
         </p:txBody>
       </p:sp>
-      <p:pic>
-        <p:nvPicPr>
-          <p:cNvPr id="3" name="Image 0" descr="TuitionPilot architecture diagram"/>
-          <p:cNvPicPr>
-            <a:picLocks noChangeAspect="1"/>
-          </p:cNvPicPr>
-          <p:nvPr/>
-        </p:nvPicPr>
-        <p:blipFill>
-          <a:blip r:embed="rId3"/>
-          <a:stretch>
-            <a:fillRect/>
-          </a:stretch>
-        </p:blipFill>
-        <p:spPr>
-          <a:xfrm>
-            <a:off x="548640" y="1234440"/>
-            <a:ext cx="8046720" cy="5029200"/>
-          </a:xfrm>
-          <a:prstGeom prst="rect">
-            <a:avLst/>
-          </a:prstGeom>
-        </p:spPr>
-      </p:pic>
       <p:sp>
         <p:nvSpPr>
           <p:cNvPr id="4" name="Shape 1"/>
@@ -8706,7 +8712,7 @@
           </a:prstGeom>
           <a:extLst>
             <a:ext uri="{C572A759-6A51-4108-AA02-DFA0A04FC94B}">
-              <ma14:wrappingTextBoxFlag xmlns="" xmlns:ma14="http://schemas.microsoft.com/office/mac/drawingml/2011/main" val="0"/>
+              <ma14:wrappingTextBoxFlag xmlns:ma14="http://schemas.microsoft.com/office/mac/drawingml/2011/main" xmlns="" val="0"/>
             </a:ext>
           </a:extLst>
         </p:spPr>
@@ -10684,7 +10690,7 @@
           </a:prstGeom>
           <a:extLst>
             <a:ext uri="{C572A759-6A51-4108-AA02-DFA0A04FC94B}">
-              <ma14:wrappingTextBoxFlag xmlns="" xmlns:ma14="http://schemas.microsoft.com/office/mac/drawingml/2011/main" val="0"/>
+              <ma14:wrappingTextBoxFlag xmlns:ma14="http://schemas.microsoft.com/office/mac/drawingml/2011/main" xmlns="" val="0"/>
             </a:ext>
           </a:extLst>
         </p:spPr>
@@ -11304,7 +11310,7 @@
           </a:prstGeom>
           <a:extLst>
             <a:ext uri="{C572A759-6A51-4108-AA02-DFA0A04FC94B}">
-              <ma14:wrappingTextBoxFlag xmlns="" xmlns:ma14="http://schemas.microsoft.com/office/mac/drawingml/2011/main" val="0"/>
+              <ma14:wrappingTextBoxFlag xmlns:ma14="http://schemas.microsoft.com/office/mac/drawingml/2011/main" xmlns="" val="0"/>
             </a:ext>
           </a:extLst>
         </p:spPr>
@@ -12899,7 +12905,7 @@
           </a:prstGeom>
           <a:extLst>
             <a:ext uri="{C572A759-6A51-4108-AA02-DFA0A04FC94B}">
-              <ma14:wrappingTextBoxFlag xmlns="" xmlns:ma14="http://schemas.microsoft.com/office/mac/drawingml/2011/main" val="0"/>
+              <ma14:wrappingTextBoxFlag xmlns:ma14="http://schemas.microsoft.com/office/mac/drawingml/2011/main" xmlns="" val="0"/>
             </a:ext>
           </a:extLst>
         </p:spPr>
@@ -14966,7 +14972,7 @@
           </a:prstGeom>
           <a:extLst>
             <a:ext uri="{C572A759-6A51-4108-AA02-DFA0A04FC94B}">
-              <ma14:wrappingTextBoxFlag xmlns="" xmlns:ma14="http://schemas.microsoft.com/office/mac/drawingml/2011/main" val="0"/>
+              <ma14:wrappingTextBoxFlag xmlns:ma14="http://schemas.microsoft.com/office/mac/drawingml/2011/main" xmlns="" val="0"/>
             </a:ext>
           </a:extLst>
         </p:spPr>

</xml_diff>